<commit_message>
docs(presentation): a real architecture diagram on slide 4
Slide 4 was a grid of text boxes, not a diagram - no flow, no arrows, and
nothing showing where the boundary between the engines and the model sits.

Redrawn as an actual four-tier diagram in the deck's own palette:

  clients        dashboard · IBM Bob · real telemetry
       |
  policy.js      read · propose · COMMIT   (amber, the gate everything passes
                 through; a refused commit is appended to the hash chain)
       |
  engines        viabilityClock · regulatoryEngine · breachPredictor ·
                 graphRouter · fleetMatcher   (teal, no I/O, no wall clock)
       |
  world / watsonx / audit

The watsonx arrow is dashed and points AWAY from the decision, because the
model runs after it. That one detail is the whole architectural argument and
the previous slide could not show it.

Co-Authored-By: Claude Opus 5 (1M context) <noreply@anthropic.com>
</commit_message>
<xml_diff>
--- a/presentation/slides.pptx
+++ b/presentation/slides.pptx
@@ -3786,1261 +3786,1278 @@
       </p:sp>
       <p:sp>
         <p:nvSpPr>
-          <p:cNvPr id="5" name="Shape 3"/>
+          <p:cNvPr id="5" name="TextBox 4"/>
+          <p:cNvSpPr txBox="1"/>
+          <p:nvPr/>
+        </p:nvSpPr>
+        <p:spPr>
+          <a:xfrm>
+            <a:off x="411480" y="1078992"/>
+            <a:ext cx="1828800" cy="182880"/>
+          </a:xfrm>
+          <a:prstGeom prst="rect">
+            <a:avLst/>
+          </a:prstGeom>
+          <a:noFill/>
+        </p:spPr>
+        <p:txBody>
+          <a:bodyPr wrap="square">
+            <a:spAutoFit/>
+          </a:bodyPr>
+          <a:lstStyle/>
+          <a:p>
+            <a:pPr algn="l"/>
+            <a:r>
+              <a:rPr sz="650" b="1">
+                <a:solidFill>
+                  <a:srgbClr val="64748B"/>
+                </a:solidFill>
+                <a:latin typeface="Arial"/>
+              </a:rPr>
+              <a:t>CLIENTS</a:t>
+            </a:r>
+          </a:p>
+        </p:txBody>
+      </p:sp>
+      <p:sp>
+        <p:nvSpPr>
+          <p:cNvPr id="6" name="Rounded Rectangle 5"/>
           <p:cNvSpPr/>
           <p:nvPr/>
         </p:nvSpPr>
         <p:spPr>
           <a:xfrm>
-            <a:off x="457200" y="1280160"/>
-            <a:ext cx="1371600" cy="548640"/>
+            <a:off x="411480" y="1280160"/>
+            <a:ext cx="2377440" cy="475488"/>
           </a:xfrm>
           <a:prstGeom prst="roundRect">
-            <a:avLst>
-              <a:gd name="adj" fmla="val 10000"/>
-            </a:avLst>
+            <a:avLst/>
           </a:prstGeom>
           <a:solidFill>
             <a:srgbClr val="1F2A44"/>
           </a:solidFill>
+          <a:ln>
+            <a:noFill/>
+          </a:ln>
+          <a:effectLst/>
+        </p:spPr>
+        <p:style>
+          <a:lnRef idx="1">
+            <a:schemeClr val="accent1"/>
+          </a:lnRef>
+          <a:fillRef idx="3">
+            <a:schemeClr val="accent1"/>
+          </a:fillRef>
+          <a:effectRef idx="2">
+            <a:schemeClr val="accent1"/>
+          </a:effectRef>
+          <a:fontRef idx="minor">
+            <a:schemeClr val="lt1"/>
+          </a:fontRef>
+        </p:style>
+        <p:txBody>
+          <a:bodyPr rtlCol="0" anchor="ctr" wrap="square" lIns="45720" rIns="45720" tIns="18288" bIns="18288"/>
+          <a:lstStyle/>
+          <a:p>
+            <a:pPr algn="ctr"/>
+            <a:r>
+              <a:rPr sz="1000" b="1">
+                <a:solidFill>
+                  <a:srgbClr val="F1F5F9"/>
+                </a:solidFill>
+                <a:latin typeface="Arial"/>
+              </a:rPr>
+              <a:t>Dashboard</a:t>
+            </a:r>
+          </a:p>
+          <a:p>
+            <a:pPr algn="ctr"/>
+            <a:r>
+              <a:rPr sz="750">
+                <a:solidFill>
+                  <a:srgbClr val="94A3B8"/>
+                </a:solidFill>
+                <a:latin typeface="Arial"/>
+              </a:rPr>
+              <a:t>map · triage · audit</a:t>
+            </a:r>
+          </a:p>
+        </p:txBody>
+      </p:sp>
+      <p:sp>
+        <p:nvSpPr>
+          <p:cNvPr id="7" name="Rounded Rectangle 6"/>
+          <p:cNvSpPr/>
+          <p:nvPr/>
+        </p:nvSpPr>
+        <p:spPr>
+          <a:xfrm>
+            <a:off x="3017520" y="1280160"/>
+            <a:ext cx="2377440" cy="475488"/>
+          </a:xfrm>
+          <a:prstGeom prst="roundRect">
+            <a:avLst/>
+          </a:prstGeom>
+          <a:solidFill>
+            <a:srgbClr val="1F2A44"/>
+          </a:solidFill>
+          <a:ln w="15875">
+            <a:solidFill>
+              <a:srgbClr val="38BDF8"/>
+            </a:solidFill>
+          </a:ln>
+          <a:effectLst/>
+        </p:spPr>
+        <p:style>
+          <a:lnRef idx="1">
+            <a:schemeClr val="accent1"/>
+          </a:lnRef>
+          <a:fillRef idx="3">
+            <a:schemeClr val="accent1"/>
+          </a:fillRef>
+          <a:effectRef idx="2">
+            <a:schemeClr val="accent1"/>
+          </a:effectRef>
+          <a:fontRef idx="minor">
+            <a:schemeClr val="lt1"/>
+          </a:fontRef>
+        </p:style>
+        <p:txBody>
+          <a:bodyPr rtlCol="0" anchor="ctr" wrap="square" lIns="45720" rIns="45720" tIns="18288" bIns="18288"/>
+          <a:lstStyle/>
+          <a:p>
+            <a:pPr algn="ctr"/>
+            <a:r>
+              <a:rPr sz="1000" b="1">
+                <a:solidFill>
+                  <a:srgbClr val="F1F5F9"/>
+                </a:solidFill>
+                <a:latin typeface="Arial"/>
+              </a:rPr>
+              <a:t>IBM Bob</a:t>
+            </a:r>
+          </a:p>
+          <a:p>
+            <a:pPr algn="ctr"/>
+            <a:r>
+              <a:rPr sz="750">
+                <a:solidFill>
+                  <a:srgbClr val="94A3B8"/>
+                </a:solidFill>
+                <a:latin typeface="Arial"/>
+              </a:rPr>
+              <a:t>Control Tower mode</a:t>
+            </a:r>
+          </a:p>
+        </p:txBody>
+      </p:sp>
+      <p:sp>
+        <p:nvSpPr>
+          <p:cNvPr id="8" name="Rounded Rectangle 7"/>
+          <p:cNvSpPr/>
+          <p:nvPr/>
+        </p:nvSpPr>
+        <p:spPr>
+          <a:xfrm>
+            <a:off x="5623560" y="1280160"/>
+            <a:ext cx="3108960" cy="475488"/>
+          </a:xfrm>
+          <a:prstGeom prst="roundRect">
+            <a:avLst/>
+          </a:prstGeom>
+          <a:solidFill>
+            <a:srgbClr val="1F2A44"/>
+          </a:solidFill>
+          <a:ln>
+            <a:noFill/>
+          </a:ln>
+          <a:effectLst/>
+        </p:spPr>
+        <p:style>
+          <a:lnRef idx="1">
+            <a:schemeClr val="accent1"/>
+          </a:lnRef>
+          <a:fillRef idx="3">
+            <a:schemeClr val="accent1"/>
+          </a:fillRef>
+          <a:effectRef idx="2">
+            <a:schemeClr val="accent1"/>
+          </a:effectRef>
+          <a:fontRef idx="minor">
+            <a:schemeClr val="lt1"/>
+          </a:fontRef>
+        </p:style>
+        <p:txBody>
+          <a:bodyPr rtlCol="0" anchor="ctr" wrap="square" lIns="45720" rIns="45720" tIns="18288" bIns="18288"/>
+          <a:lstStyle/>
+          <a:p>
+            <a:pPr algn="ctr"/>
+            <a:r>
+              <a:rPr sz="1000" b="1">
+                <a:solidFill>
+                  <a:srgbClr val="F1F5F9"/>
+                </a:solidFill>
+                <a:latin typeface="Arial"/>
+              </a:rPr>
+              <a:t>Real telemetry</a:t>
+            </a:r>
+          </a:p>
+          <a:p>
+            <a:pPr algn="ctr"/>
+            <a:r>
+              <a:rPr sz="750">
+                <a:solidFill>
+                  <a:srgbClr val="94A3B8"/>
+                </a:solidFill>
+                <a:latin typeface="Arial"/>
+              </a:rPr>
+              <a:t>POST /ingest/sensor</a:t>
+            </a:r>
+          </a:p>
+        </p:txBody>
+      </p:sp>
+      <p:cxnSp>
+        <p:nvCxnSpPr>
+          <p:cNvPr id="9" name="Connector 8"/>
+          <p:cNvCxnSpPr/>
+          <p:nvPr/>
+        </p:nvCxnSpPr>
+        <p:spPr>
+          <a:xfrm>
+            <a:off x="1600200" y="1755648"/>
+            <a:ext cx="0" cy="274320"/>
+          </a:xfrm>
+          <a:prstGeom prst="line">
+            <a:avLst/>
+          </a:prstGeom>
           <a:ln w="12700">
             <a:solidFill>
-              <a:srgbClr val="1F2A44"/>
+              <a:srgbClr val="64748B"/>
             </a:solidFill>
-            <a:prstDash val="solid"/>
           </a:ln>
         </p:spPr>
-      </p:sp>
-      <p:sp>
-        <p:nvSpPr>
-          <p:cNvPr id="6" name="Text 4"/>
-          <p:cNvSpPr txBox="1"/>
-          <p:nvPr/>
-        </p:nvSpPr>
-        <p:spPr>
-          <a:xfrm>
-            <a:off x="502920" y="1280160"/>
-            <a:ext cx="1280160" cy="548640"/>
-          </a:xfrm>
-          <a:prstGeom prst="rect">
-            <a:avLst/>
-          </a:prstGeom>
-          <a:noFill/>
-          <a:ln/>
-        </p:spPr>
-        <p:txBody>
-          <a:bodyPr wrap="square" lIns="0" tIns="0" rIns="0" bIns="0" rtlCol="0" anchor="ctr"/>
-          <a:lstStyle/>
-          <a:p>
-            <a:pPr marL="0" indent="0" algn="ctr">
-              <a:buNone/>
-            </a:pPr>
-            <a:r>
-              <a:rPr lang="en-US" sz="1050" b="1" dirty="0">
-                <a:solidFill>
-                  <a:srgbClr val="CBD5E1"/>
-                </a:solidFill>
-                <a:latin typeface="Calibri" pitchFamily="34" charset="0"/>
-                <a:ea typeface="Calibri" pitchFamily="34" charset="-122"/>
-                <a:cs typeface="Calibri" pitchFamily="34" charset="-120"/>
-              </a:rPr>
-              <a:t>Simulated world (motion + telemetry)</a:t>
-            </a:r>
-            <a:endParaRPr lang="en-US" sz="1050" dirty="0"/>
-          </a:p>
-        </p:txBody>
-      </p:sp>
-      <p:sp>
-        <p:nvSpPr>
-          <p:cNvPr id="7" name="Shape 5"/>
-          <p:cNvSpPr/>
-          <p:nvPr/>
-        </p:nvSpPr>
-        <p:spPr>
-          <a:xfrm>
-            <a:off x="2171700" y="1280160"/>
-            <a:ext cx="1371600" cy="548640"/>
-          </a:xfrm>
-          <a:prstGeom prst="roundRect">
-            <a:avLst>
-              <a:gd name="adj" fmla="val 10000"/>
-            </a:avLst>
-          </a:prstGeom>
-          <a:solidFill>
-            <a:srgbClr val="0E3A4A"/>
-          </a:solidFill>
+        <p:style>
+          <a:lnRef idx="2">
+            <a:schemeClr val="accent1"/>
+          </a:lnRef>
+          <a:fillRef idx="0">
+            <a:schemeClr val="accent1"/>
+          </a:fillRef>
+          <a:effectRef idx="1">
+            <a:schemeClr val="accent1"/>
+          </a:effectRef>
+          <a:fontRef idx="minor">
+            <a:schemeClr val="tx1"/>
+          </a:fontRef>
+        </p:style>
+      </p:cxnSp>
+      <p:cxnSp>
+        <p:nvCxnSpPr>
+          <p:cNvPr id="10" name="Connector 9"/>
+          <p:cNvCxnSpPr/>
+          <p:nvPr/>
+        </p:nvCxnSpPr>
+        <p:spPr>
+          <a:xfrm>
+            <a:off x="4206240" y="1755648"/>
+            <a:ext cx="0" cy="274320"/>
+          </a:xfrm>
+          <a:prstGeom prst="line">
+            <a:avLst/>
+          </a:prstGeom>
+          <a:ln w="15875">
+            <a:solidFill>
+              <a:srgbClr val="38BDF8"/>
+            </a:solidFill>
+          </a:ln>
+        </p:spPr>
+        <p:style>
+          <a:lnRef idx="2">
+            <a:schemeClr val="accent1"/>
+          </a:lnRef>
+          <a:fillRef idx="0">
+            <a:schemeClr val="accent1"/>
+          </a:fillRef>
+          <a:effectRef idx="1">
+            <a:schemeClr val="accent1"/>
+          </a:effectRef>
+          <a:fontRef idx="minor">
+            <a:schemeClr val="tx1"/>
+          </a:fontRef>
+        </p:style>
+      </p:cxnSp>
+      <p:cxnSp>
+        <p:nvCxnSpPr>
+          <p:cNvPr id="11" name="Connector 10"/>
+          <p:cNvCxnSpPr/>
+          <p:nvPr/>
+        </p:nvCxnSpPr>
+        <p:spPr>
+          <a:xfrm>
+            <a:off x="7178040" y="1755648"/>
+            <a:ext cx="0" cy="274320"/>
+          </a:xfrm>
+          <a:prstGeom prst="line">
+            <a:avLst/>
+          </a:prstGeom>
           <a:ln w="12700">
             <a:solidFill>
-              <a:srgbClr val="0E3A4A"/>
+              <a:srgbClr val="64748B"/>
             </a:solidFill>
-            <a:prstDash val="solid"/>
           </a:ln>
         </p:spPr>
-      </p:sp>
-      <p:sp>
-        <p:nvSpPr>
-          <p:cNvPr id="8" name="Text 6"/>
+        <p:style>
+          <a:lnRef idx="2">
+            <a:schemeClr val="accent1"/>
+          </a:lnRef>
+          <a:fillRef idx="0">
+            <a:schemeClr val="accent1"/>
+          </a:fillRef>
+          <a:effectRef idx="1">
+            <a:schemeClr val="accent1"/>
+          </a:effectRef>
+          <a:fontRef idx="minor">
+            <a:schemeClr val="tx1"/>
+          </a:fontRef>
+        </p:style>
+      </p:cxnSp>
+      <p:sp>
+        <p:nvSpPr>
+          <p:cNvPr id="12" name="Rounded Rectangle 11"/>
+          <p:cNvSpPr/>
+          <p:nvPr/>
+        </p:nvSpPr>
+        <p:spPr>
+          <a:xfrm>
+            <a:off x="411480" y="2029968"/>
+            <a:ext cx="8321040" cy="420624"/>
+          </a:xfrm>
+          <a:prstGeom prst="roundRect">
+            <a:avLst/>
+          </a:prstGeom>
+          <a:solidFill>
+            <a:srgbClr val="4A2A1A"/>
+          </a:solidFill>
+          <a:ln w="15875">
+            <a:solidFill>
+              <a:srgbClr val="F59E0B"/>
+            </a:solidFill>
+          </a:ln>
+          <a:effectLst/>
+        </p:spPr>
+        <p:style>
+          <a:lnRef idx="1">
+            <a:schemeClr val="accent1"/>
+          </a:lnRef>
+          <a:fillRef idx="3">
+            <a:schemeClr val="accent1"/>
+          </a:fillRef>
+          <a:effectRef idx="2">
+            <a:schemeClr val="accent1"/>
+          </a:effectRef>
+          <a:fontRef idx="minor">
+            <a:schemeClr val="lt1"/>
+          </a:fontRef>
+        </p:style>
+        <p:txBody>
+          <a:bodyPr rtlCol="0" anchor="ctr" wrap="square" lIns="45720" rIns="45720" tIns="18288" bIns="18288"/>
+          <a:lstStyle/>
+          <a:p>
+            <a:pPr algn="ctr"/>
+            <a:r>
+              <a:rPr sz="1000" b="1">
+                <a:solidFill>
+                  <a:srgbClr val="F1F5F9"/>
+                </a:solidFill>
+                <a:latin typeface="Arial"/>
+              </a:rPr>
+              <a:t>policy.js  —  read · propose · COMMIT</a:t>
+            </a:r>
+          </a:p>
+          <a:p>
+            <a:pPr algn="ctr"/>
+            <a:r>
+              <a:rPr sz="700">
+                <a:solidFill>
+                  <a:srgbClr val="94A3B8"/>
+                </a:solidFill>
+                <a:latin typeface="Arial"/>
+              </a:rPr>
+              <a:t>an agent may read and propose · only a human may commit</a:t>
+            </a:r>
+          </a:p>
+        </p:txBody>
+      </p:sp>
+      <p:sp>
+        <p:nvSpPr>
+          <p:cNvPr id="13" name="TextBox 12"/>
           <p:cNvSpPr txBox="1"/>
           <p:nvPr/>
         </p:nvSpPr>
         <p:spPr>
           <a:xfrm>
-            <a:off x="2217420" y="1280160"/>
-            <a:ext cx="1280160" cy="548640"/>
+            <a:off x="411480" y="2468880"/>
+            <a:ext cx="3657600" cy="182880"/>
           </a:xfrm>
           <a:prstGeom prst="rect">
             <a:avLst/>
           </a:prstGeom>
           <a:noFill/>
-          <a:ln/>
-        </p:spPr>
-        <p:txBody>
-          <a:bodyPr wrap="square" lIns="0" tIns="0" rIns="0" bIns="0" rtlCol="0" anchor="ctr"/>
-          <a:lstStyle/>
-          <a:p>
-            <a:pPr marL="0" indent="0" algn="ctr">
-              <a:buNone/>
-            </a:pPr>
-            <a:r>
-              <a:rPr lang="en-US" sz="1050" b="1" dirty="0">
-                <a:solidFill>
-                  <a:srgbClr val="A5F3FC"/>
-                </a:solidFill>
-                <a:latin typeface="Calibri" pitchFamily="34" charset="0"/>
-                <a:ea typeface="Calibri" pitchFamily="34" charset="-122"/>
-                <a:cs typeface="Calibri" pitchFamily="34" charset="-120"/>
-              </a:rPr>
-              <a:t>Sensor sanity → Regulatory engine</a:t>
-            </a:r>
-            <a:endParaRPr lang="en-US" sz="1050" dirty="0"/>
-          </a:p>
-        </p:txBody>
-      </p:sp>
-      <p:sp>
-        <p:nvSpPr>
-          <p:cNvPr id="9" name="Shape 7"/>
+        </p:spPr>
+        <p:txBody>
+          <a:bodyPr wrap="square">
+            <a:spAutoFit/>
+          </a:bodyPr>
+          <a:lstStyle/>
+          <a:p>
+            <a:pPr algn="l"/>
+            <a:r>
+              <a:rPr sz="650" b="1">
+                <a:solidFill>
+                  <a:srgbClr val="F59E0B"/>
+                </a:solidFill>
+                <a:latin typeface="Arial"/>
+              </a:rPr>
+              <a:t>▲  a refused commit is appended to the hash chain</a:t>
+            </a:r>
+          </a:p>
+        </p:txBody>
+      </p:sp>
+      <p:sp>
+        <p:nvSpPr>
+          <p:cNvPr id="14" name="TextBox 13"/>
+          <p:cNvSpPr txBox="1"/>
+          <p:nvPr/>
+        </p:nvSpPr>
+        <p:spPr>
+          <a:xfrm>
+            <a:off x="411480" y="2697480"/>
+            <a:ext cx="4114800" cy="182880"/>
+          </a:xfrm>
+          <a:prstGeom prst="rect">
+            <a:avLst/>
+          </a:prstGeom>
+          <a:noFill/>
+        </p:spPr>
+        <p:txBody>
+          <a:bodyPr wrap="square">
+            <a:spAutoFit/>
+          </a:bodyPr>
+          <a:lstStyle/>
+          <a:p>
+            <a:pPr algn="l"/>
+            <a:r>
+              <a:rPr sz="650" b="1">
+                <a:solidFill>
+                  <a:srgbClr val="64748B"/>
+                </a:solidFill>
+                <a:latin typeface="Arial"/>
+              </a:rPr>
+              <a:t>DETERMINISTIC ENGINES   no I/O · no wall clock · 165 tests</a:t>
+            </a:r>
+          </a:p>
+        </p:txBody>
+      </p:sp>
+      <p:sp>
+        <p:nvSpPr>
+          <p:cNvPr id="15" name="Rounded Rectangle 14"/>
           <p:cNvSpPr/>
           <p:nvPr/>
         </p:nvSpPr>
         <p:spPr>
           <a:xfrm>
-            <a:off x="3886200" y="1280160"/>
-            <a:ext cx="1371600" cy="548640"/>
+            <a:off x="411480" y="2898648"/>
+            <a:ext cx="1627632" cy="457200"/>
           </a:xfrm>
           <a:prstGeom prst="roundRect">
-            <a:avLst>
-              <a:gd name="adj" fmla="val 10000"/>
-            </a:avLst>
+            <a:avLst/>
+          </a:prstGeom>
+          <a:solidFill>
+            <a:srgbClr val="0E3A4A"/>
+          </a:solidFill>
+          <a:ln>
+            <a:noFill/>
+          </a:ln>
+          <a:effectLst/>
+        </p:spPr>
+        <p:style>
+          <a:lnRef idx="1">
+            <a:schemeClr val="accent1"/>
+          </a:lnRef>
+          <a:fillRef idx="3">
+            <a:schemeClr val="accent1"/>
+          </a:fillRef>
+          <a:effectRef idx="2">
+            <a:schemeClr val="accent1"/>
+          </a:effectRef>
+          <a:fontRef idx="minor">
+            <a:schemeClr val="lt1"/>
+          </a:fontRef>
+        </p:style>
+        <p:txBody>
+          <a:bodyPr rtlCol="0" anchor="ctr" wrap="square" lIns="45720" rIns="45720" tIns="18288" bIns="18288"/>
+          <a:lstStyle/>
+          <a:p>
+            <a:pPr algn="ctr"/>
+            <a:r>
+              <a:rPr sz="850" b="1">
+                <a:solidFill>
+                  <a:srgbClr val="F1F5F9"/>
+                </a:solidFill>
+                <a:latin typeface="Arial"/>
+              </a:rPr>
+              <a:t>viabilityClock</a:t>
+            </a:r>
+          </a:p>
+          <a:p>
+            <a:pPr algn="ctr"/>
+            <a:r>
+              <a:rPr sz="650">
+                <a:solidFill>
+                  <a:srgbClr val="94A3B8"/>
+                </a:solidFill>
+                <a:latin typeface="Arial"/>
+              </a:rPr>
+              <a:t>two clocks</a:t>
+            </a:r>
+          </a:p>
+        </p:txBody>
+      </p:sp>
+      <p:sp>
+        <p:nvSpPr>
+          <p:cNvPr id="16" name="Rounded Rectangle 15"/>
+          <p:cNvSpPr/>
+          <p:nvPr/>
+        </p:nvSpPr>
+        <p:spPr>
+          <a:xfrm>
+            <a:off x="2084832" y="2898648"/>
+            <a:ext cx="1627632" cy="457200"/>
+          </a:xfrm>
+          <a:prstGeom prst="roundRect">
+            <a:avLst/>
+          </a:prstGeom>
+          <a:solidFill>
+            <a:srgbClr val="0E3A4A"/>
+          </a:solidFill>
+          <a:ln>
+            <a:noFill/>
+          </a:ln>
+          <a:effectLst/>
+        </p:spPr>
+        <p:style>
+          <a:lnRef idx="1">
+            <a:schemeClr val="accent1"/>
+          </a:lnRef>
+          <a:fillRef idx="3">
+            <a:schemeClr val="accent1"/>
+          </a:fillRef>
+          <a:effectRef idx="2">
+            <a:schemeClr val="accent1"/>
+          </a:effectRef>
+          <a:fontRef idx="minor">
+            <a:schemeClr val="lt1"/>
+          </a:fontRef>
+        </p:style>
+        <p:txBody>
+          <a:bodyPr rtlCol="0" anchor="ctr" wrap="square" lIns="45720" rIns="45720" tIns="18288" bIns="18288"/>
+          <a:lstStyle/>
+          <a:p>
+            <a:pPr algn="ctr"/>
+            <a:r>
+              <a:rPr sz="850" b="1">
+                <a:solidFill>
+                  <a:srgbClr val="F1F5F9"/>
+                </a:solidFill>
+                <a:latin typeface="Arial"/>
+              </a:rPr>
+              <a:t>regulatoryEngine</a:t>
+            </a:r>
+          </a:p>
+          <a:p>
+            <a:pPr algn="ctr"/>
+            <a:r>
+              <a:rPr sz="650">
+                <a:solidFill>
+                  <a:srgbClr val="94A3B8"/>
+                </a:solidFill>
+                <a:latin typeface="Arial"/>
+              </a:rPr>
+              <a:t>matrix · MKT</a:t>
+            </a:r>
+          </a:p>
+        </p:txBody>
+      </p:sp>
+      <p:sp>
+        <p:nvSpPr>
+          <p:cNvPr id="17" name="Rounded Rectangle 16"/>
+          <p:cNvSpPr/>
+          <p:nvPr/>
+        </p:nvSpPr>
+        <p:spPr>
+          <a:xfrm>
+            <a:off x="3758184" y="2898648"/>
+            <a:ext cx="1627632" cy="457200"/>
+          </a:xfrm>
+          <a:prstGeom prst="roundRect">
+            <a:avLst/>
+          </a:prstGeom>
+          <a:solidFill>
+            <a:srgbClr val="0E3A4A"/>
+          </a:solidFill>
+          <a:ln>
+            <a:noFill/>
+          </a:ln>
+          <a:effectLst/>
+        </p:spPr>
+        <p:style>
+          <a:lnRef idx="1">
+            <a:schemeClr val="accent1"/>
+          </a:lnRef>
+          <a:fillRef idx="3">
+            <a:schemeClr val="accent1"/>
+          </a:fillRef>
+          <a:effectRef idx="2">
+            <a:schemeClr val="accent1"/>
+          </a:effectRef>
+          <a:fontRef idx="minor">
+            <a:schemeClr val="lt1"/>
+          </a:fontRef>
+        </p:style>
+        <p:txBody>
+          <a:bodyPr rtlCol="0" anchor="ctr" wrap="square" lIns="45720" rIns="45720" tIns="18288" bIns="18288"/>
+          <a:lstStyle/>
+          <a:p>
+            <a:pPr algn="ctr"/>
+            <a:r>
+              <a:rPr sz="850" b="1">
+                <a:solidFill>
+                  <a:srgbClr val="F1F5F9"/>
+                </a:solidFill>
+                <a:latin typeface="Arial"/>
+              </a:rPr>
+              <a:t>breachPredictor</a:t>
+            </a:r>
+          </a:p>
+          <a:p>
+            <a:pPr algn="ctr"/>
+            <a:r>
+              <a:rPr sz="650">
+                <a:solidFill>
+                  <a:srgbClr val="94A3B8"/>
+                </a:solidFill>
+                <a:latin typeface="Arial"/>
+              </a:rPr>
+              <a:t>Newton fit</a:t>
+            </a:r>
+          </a:p>
+        </p:txBody>
+      </p:sp>
+      <p:sp>
+        <p:nvSpPr>
+          <p:cNvPr id="18" name="Rounded Rectangle 17"/>
+          <p:cNvSpPr/>
+          <p:nvPr/>
+        </p:nvSpPr>
+        <p:spPr>
+          <a:xfrm>
+            <a:off x="5431536" y="2898648"/>
+            <a:ext cx="1627632" cy="457200"/>
+          </a:xfrm>
+          <a:prstGeom prst="roundRect">
+            <a:avLst/>
+          </a:prstGeom>
+          <a:solidFill>
+            <a:srgbClr val="0E3A4A"/>
+          </a:solidFill>
+          <a:ln>
+            <a:noFill/>
+          </a:ln>
+          <a:effectLst/>
+        </p:spPr>
+        <p:style>
+          <a:lnRef idx="1">
+            <a:schemeClr val="accent1"/>
+          </a:lnRef>
+          <a:fillRef idx="3">
+            <a:schemeClr val="accent1"/>
+          </a:fillRef>
+          <a:effectRef idx="2">
+            <a:schemeClr val="accent1"/>
+          </a:effectRef>
+          <a:fontRef idx="minor">
+            <a:schemeClr val="lt1"/>
+          </a:fontRef>
+        </p:style>
+        <p:txBody>
+          <a:bodyPr rtlCol="0" anchor="ctr" wrap="square" lIns="45720" rIns="45720" tIns="18288" bIns="18288"/>
+          <a:lstStyle/>
+          <a:p>
+            <a:pPr algn="ctr"/>
+            <a:r>
+              <a:rPr sz="850" b="1">
+                <a:solidFill>
+                  <a:srgbClr val="F1F5F9"/>
+                </a:solidFill>
+                <a:latin typeface="Arial"/>
+              </a:rPr>
+              <a:t>graphRouter</a:t>
+            </a:r>
+          </a:p>
+          <a:p>
+            <a:pPr algn="ctr"/>
+            <a:r>
+              <a:rPr sz="650">
+                <a:solidFill>
+                  <a:srgbClr val="94A3B8"/>
+                </a:solidFill>
+                <a:latin typeface="Arial"/>
+              </a:rPr>
+              <a:t>+ landedCost</a:t>
+            </a:r>
+          </a:p>
+        </p:txBody>
+      </p:sp>
+      <p:sp>
+        <p:nvSpPr>
+          <p:cNvPr id="19" name="Rounded Rectangle 18"/>
+          <p:cNvSpPr/>
+          <p:nvPr/>
+        </p:nvSpPr>
+        <p:spPr>
+          <a:xfrm>
+            <a:off x="7104888" y="2898648"/>
+            <a:ext cx="1627632" cy="457200"/>
+          </a:xfrm>
+          <a:prstGeom prst="roundRect">
+            <a:avLst/>
+          </a:prstGeom>
+          <a:solidFill>
+            <a:srgbClr val="0E3A4A"/>
+          </a:solidFill>
+          <a:ln>
+            <a:noFill/>
+          </a:ln>
+          <a:effectLst/>
+        </p:spPr>
+        <p:style>
+          <a:lnRef idx="1">
+            <a:schemeClr val="accent1"/>
+          </a:lnRef>
+          <a:fillRef idx="3">
+            <a:schemeClr val="accent1"/>
+          </a:fillRef>
+          <a:effectRef idx="2">
+            <a:schemeClr val="accent1"/>
+          </a:effectRef>
+          <a:fontRef idx="minor">
+            <a:schemeClr val="lt1"/>
+          </a:fontRef>
+        </p:style>
+        <p:txBody>
+          <a:bodyPr rtlCol="0" anchor="ctr" wrap="square" lIns="45720" rIns="45720" tIns="18288" bIns="18288"/>
+          <a:lstStyle/>
+          <a:p>
+            <a:pPr algn="ctr"/>
+            <a:r>
+              <a:rPr sz="850" b="1">
+                <a:solidFill>
+                  <a:srgbClr val="F1F5F9"/>
+                </a:solidFill>
+                <a:latin typeface="Arial"/>
+              </a:rPr>
+              <a:t>fleetMatcher</a:t>
+            </a:r>
+          </a:p>
+          <a:p>
+            <a:pPr algn="ctr"/>
+            <a:r>
+              <a:rPr sz="650">
+                <a:solidFill>
+                  <a:srgbClr val="94A3B8"/>
+                </a:solidFill>
+                <a:latin typeface="Arial"/>
+              </a:rPr>
+              <a:t>0–100 score</a:t>
+            </a:r>
+          </a:p>
+        </p:txBody>
+      </p:sp>
+      <p:cxnSp>
+        <p:nvCxnSpPr>
+          <p:cNvPr id="20" name="Connector 19"/>
+          <p:cNvCxnSpPr/>
+          <p:nvPr/>
+        </p:nvCxnSpPr>
+        <p:spPr>
+          <a:xfrm>
+            <a:off x="4206240" y="2450592"/>
+            <a:ext cx="0" cy="448056"/>
+          </a:xfrm>
+          <a:prstGeom prst="line">
+            <a:avLst/>
+          </a:prstGeom>
+          <a:ln w="15875">
+            <a:solidFill>
+              <a:srgbClr val="22C55E"/>
+            </a:solidFill>
+          </a:ln>
+        </p:spPr>
+        <p:style>
+          <a:lnRef idx="2">
+            <a:schemeClr val="accent1"/>
+          </a:lnRef>
+          <a:fillRef idx="0">
+            <a:schemeClr val="accent1"/>
+          </a:fillRef>
+          <a:effectRef idx="1">
+            <a:schemeClr val="accent1"/>
+          </a:effectRef>
+          <a:fontRef idx="minor">
+            <a:schemeClr val="tx1"/>
+          </a:fontRef>
+        </p:style>
+      </p:cxnSp>
+      <p:sp>
+        <p:nvSpPr>
+          <p:cNvPr id="21" name="Rounded Rectangle 20"/>
+          <p:cNvSpPr/>
+          <p:nvPr/>
+        </p:nvSpPr>
+        <p:spPr>
+          <a:xfrm>
+            <a:off x="411480" y="3547872"/>
+            <a:ext cx="2697480" cy="420624"/>
+          </a:xfrm>
+          <a:prstGeom prst="roundRect">
+            <a:avLst/>
+          </a:prstGeom>
+          <a:solidFill>
+            <a:srgbClr val="1F2A44"/>
+          </a:solidFill>
+          <a:ln>
+            <a:noFill/>
+          </a:ln>
+          <a:effectLst/>
+        </p:spPr>
+        <p:style>
+          <a:lnRef idx="1">
+            <a:schemeClr val="accent1"/>
+          </a:lnRef>
+          <a:fillRef idx="3">
+            <a:schemeClr val="accent1"/>
+          </a:fillRef>
+          <a:effectRef idx="2">
+            <a:schemeClr val="accent1"/>
+          </a:effectRef>
+          <a:fontRef idx="minor">
+            <a:schemeClr val="lt1"/>
+          </a:fontRef>
+        </p:style>
+        <p:txBody>
+          <a:bodyPr rtlCol="0" anchor="ctr" wrap="square" lIns="45720" rIns="45720" tIns="18288" bIns="18288"/>
+          <a:lstStyle/>
+          <a:p>
+            <a:pPr algn="ctr"/>
+            <a:r>
+              <a:rPr sz="850" b="1">
+                <a:solidFill>
+                  <a:srgbClr val="F1F5F9"/>
+                </a:solidFill>
+                <a:latin typeface="Arial"/>
+              </a:rPr>
+              <a:t>Simulated world</a:t>
+            </a:r>
+          </a:p>
+          <a:p>
+            <a:pPr algn="ctr"/>
+            <a:r>
+              <a:rPr sz="650">
+                <a:solidFill>
+                  <a:srgbClr val="94A3B8"/>
+                </a:solidFill>
+                <a:latin typeface="Arial"/>
+              </a:rPr>
+              <a:t>clock · motion · telemetry</a:t>
+            </a:r>
+          </a:p>
+        </p:txBody>
+      </p:sp>
+      <p:sp>
+        <p:nvSpPr>
+          <p:cNvPr id="22" name="Rounded Rectangle 21"/>
+          <p:cNvSpPr/>
+          <p:nvPr/>
+        </p:nvSpPr>
+        <p:spPr>
+          <a:xfrm>
+            <a:off x="3246120" y="3547872"/>
+            <a:ext cx="2697480" cy="420624"/>
+          </a:xfrm>
+          <a:prstGeom prst="roundRect">
+            <a:avLst/>
           </a:prstGeom>
           <a:solidFill>
             <a:srgbClr val="2A2560"/>
           </a:solidFill>
+          <a:ln>
+            <a:noFill/>
+          </a:ln>
+          <a:effectLst/>
+        </p:spPr>
+        <p:style>
+          <a:lnRef idx="1">
+            <a:schemeClr val="accent1"/>
+          </a:lnRef>
+          <a:fillRef idx="3">
+            <a:schemeClr val="accent1"/>
+          </a:fillRef>
+          <a:effectRef idx="2">
+            <a:schemeClr val="accent1"/>
+          </a:effectRef>
+          <a:fontRef idx="minor">
+            <a:schemeClr val="lt1"/>
+          </a:fontRef>
+        </p:style>
+        <p:txBody>
+          <a:bodyPr rtlCol="0" anchor="ctr" wrap="square" lIns="45720" rIns="45720" tIns="18288" bIns="18288"/>
+          <a:lstStyle/>
+          <a:p>
+            <a:pPr algn="ctr"/>
+            <a:r>
+              <a:rPr sz="850" b="1">
+                <a:solidFill>
+                  <a:srgbClr val="F1F5F9"/>
+                </a:solidFill>
+                <a:latin typeface="Arial"/>
+              </a:rPr>
+              <a:t>watsonx.ai</a:t>
+            </a:r>
+          </a:p>
+          <a:p>
+            <a:pPr algn="ctr"/>
+            <a:r>
+              <a:rPr sz="650">
+                <a:solidFill>
+                  <a:srgbClr val="94A3B8"/>
+                </a:solidFill>
+                <a:latin typeface="Arial"/>
+              </a:rPr>
+              <a:t>explains — never decides</a:t>
+            </a:r>
+          </a:p>
+        </p:txBody>
+      </p:sp>
+      <p:sp>
+        <p:nvSpPr>
+          <p:cNvPr id="23" name="Rounded Rectangle 22"/>
+          <p:cNvSpPr/>
+          <p:nvPr/>
+        </p:nvSpPr>
+        <p:spPr>
+          <a:xfrm>
+            <a:off x="6080760" y="3547872"/>
+            <a:ext cx="2651760" cy="420624"/>
+          </a:xfrm>
+          <a:prstGeom prst="roundRect">
+            <a:avLst/>
+          </a:prstGeom>
+          <a:solidFill>
+            <a:srgbClr val="1F2A44"/>
+          </a:solidFill>
+          <a:ln w="15875">
+            <a:solidFill>
+              <a:srgbClr val="22C55E"/>
+            </a:solidFill>
+          </a:ln>
+          <a:effectLst/>
+        </p:spPr>
+        <p:style>
+          <a:lnRef idx="1">
+            <a:schemeClr val="accent1"/>
+          </a:lnRef>
+          <a:fillRef idx="3">
+            <a:schemeClr val="accent1"/>
+          </a:fillRef>
+          <a:effectRef idx="2">
+            <a:schemeClr val="accent1"/>
+          </a:effectRef>
+          <a:fontRef idx="minor">
+            <a:schemeClr val="lt1"/>
+          </a:fontRef>
+        </p:style>
+        <p:txBody>
+          <a:bodyPr rtlCol="0" anchor="ctr" wrap="square" lIns="45720" rIns="45720" tIns="18288" bIns="18288"/>
+          <a:lstStyle/>
+          <a:p>
+            <a:pPr algn="ctr"/>
+            <a:r>
+              <a:rPr sz="850" b="1">
+                <a:solidFill>
+                  <a:srgbClr val="F1F5F9"/>
+                </a:solidFill>
+                <a:latin typeface="Arial"/>
+              </a:rPr>
+              <a:t>Hash-chained audit</a:t>
+            </a:r>
+          </a:p>
+          <a:p>
+            <a:pPr algn="ctr"/>
+            <a:r>
+              <a:rPr sz="650">
+                <a:solidFill>
+                  <a:srgbClr val="94A3B8"/>
+                </a:solidFill>
+                <a:latin typeface="Arial"/>
+              </a:rPr>
+              <a:t>verifiable on screen</a:t>
+            </a:r>
+          </a:p>
+        </p:txBody>
+      </p:sp>
+      <p:cxnSp>
+        <p:nvCxnSpPr>
+          <p:cNvPr id="24" name="Connector 23"/>
+          <p:cNvCxnSpPr/>
+          <p:nvPr/>
+        </p:nvCxnSpPr>
+        <p:spPr>
+          <a:xfrm flipV="1">
+            <a:off x="1755648" y="3355848"/>
+            <a:ext cx="0" cy="192024"/>
+          </a:xfrm>
+          <a:prstGeom prst="line">
+            <a:avLst/>
+          </a:prstGeom>
+          <a:ln w="12700">
+            <a:solidFill>
+              <a:srgbClr val="64748B"/>
+            </a:solidFill>
+          </a:ln>
+        </p:spPr>
+        <p:style>
+          <a:lnRef idx="2">
+            <a:schemeClr val="accent1"/>
+          </a:lnRef>
+          <a:fillRef idx="0">
+            <a:schemeClr val="accent1"/>
+          </a:fillRef>
+          <a:effectRef idx="1">
+            <a:schemeClr val="accent1"/>
+          </a:effectRef>
+          <a:fontRef idx="minor">
+            <a:schemeClr val="tx1"/>
+          </a:fontRef>
+        </p:style>
+      </p:cxnSp>
+      <p:cxnSp>
+        <p:nvCxnSpPr>
+          <p:cNvPr id="25" name="Connector 24"/>
+          <p:cNvCxnSpPr/>
+          <p:nvPr/>
+        </p:nvCxnSpPr>
+        <p:spPr>
+          <a:xfrm>
+            <a:off x="4590288" y="3355848"/>
+            <a:ext cx="0" cy="192024"/>
+          </a:xfrm>
+          <a:prstGeom prst="line">
+            <a:avLst/>
+          </a:prstGeom>
           <a:ln w="12700">
             <a:solidFill>
               <a:srgbClr val="2A2560"/>
             </a:solidFill>
-            <a:prstDash val="solid"/>
+            <a:prstDash val="dash"/>
           </a:ln>
         </p:spPr>
-      </p:sp>
-      <p:sp>
-        <p:nvSpPr>
-          <p:cNvPr id="10" name="Text 8"/>
-          <p:cNvSpPr txBox="1"/>
-          <p:nvPr/>
-        </p:nvSpPr>
-        <p:spPr>
-          <a:xfrm>
-            <a:off x="3931920" y="1280160"/>
-            <a:ext cx="1280160" cy="548640"/>
-          </a:xfrm>
-          <a:prstGeom prst="rect">
-            <a:avLst/>
-          </a:prstGeom>
-          <a:noFill/>
-          <a:ln/>
-        </p:spPr>
-        <p:txBody>
-          <a:bodyPr wrap="square" lIns="0" tIns="0" rIns="0" bIns="0" rtlCol="0" anchor="ctr"/>
-          <a:lstStyle/>
-          <a:p>
-            <a:pPr marL="0" indent="0" algn="ctr">
-              <a:buNone/>
-            </a:pPr>
-            <a:r>
-              <a:rPr lang="en-US" sz="1050" b="1" dirty="0">
-                <a:solidFill>
-                  <a:srgbClr val="DDD6FE"/>
-                </a:solidFill>
-                <a:latin typeface="Calibri" pitchFamily="34" charset="0"/>
-                <a:ea typeface="Calibri" pitchFamily="34" charset="-122"/>
-                <a:cs typeface="Calibri" pitchFamily="34" charset="-120"/>
-              </a:rPr>
-              <a:t>watsonx (Granite-ready) explains only</a:t>
-            </a:r>
-            <a:endParaRPr lang="en-US" sz="1050" dirty="0"/>
-          </a:p>
-        </p:txBody>
-      </p:sp>
-      <p:sp>
-        <p:nvSpPr>
-          <p:cNvPr id="11" name="Shape 9"/>
-          <p:cNvSpPr/>
-          <p:nvPr/>
-        </p:nvSpPr>
-        <p:spPr>
-          <a:xfrm>
-            <a:off x="1865376" y="1554480"/>
-            <a:ext cx="274320" cy="0"/>
+        <p:style>
+          <a:lnRef idx="2">
+            <a:schemeClr val="accent1"/>
+          </a:lnRef>
+          <a:fillRef idx="0">
+            <a:schemeClr val="accent1"/>
+          </a:fillRef>
+          <a:effectRef idx="1">
+            <a:schemeClr val="accent1"/>
+          </a:effectRef>
+          <a:fontRef idx="minor">
+            <a:schemeClr val="tx1"/>
+          </a:fontRef>
+        </p:style>
+      </p:cxnSp>
+      <p:cxnSp>
+        <p:nvCxnSpPr>
+          <p:cNvPr id="26" name="Connector 25"/>
+          <p:cNvCxnSpPr/>
+          <p:nvPr/>
+        </p:nvCxnSpPr>
+        <p:spPr>
+          <a:xfrm>
+            <a:off x="7406640" y="3355848"/>
+            <a:ext cx="0" cy="192024"/>
           </a:xfrm>
           <a:prstGeom prst="line">
             <a:avLst/>
           </a:prstGeom>
-          <a:noFill/>
-          <a:ln w="15875">
-            <a:solidFill>
-              <a:srgbClr val="94A3B8"/>
-            </a:solidFill>
-            <a:prstDash val="solid"/>
-            <a:tailEnd type="triangle"/>
-          </a:ln>
-        </p:spPr>
-      </p:sp>
-      <p:sp>
-        <p:nvSpPr>
-          <p:cNvPr id="12" name="Shape 10"/>
-          <p:cNvSpPr/>
-          <p:nvPr/>
-        </p:nvSpPr>
-        <p:spPr>
-          <a:xfrm>
-            <a:off x="3579876" y="1554480"/>
-            <a:ext cx="274320" cy="0"/>
-          </a:xfrm>
-          <a:prstGeom prst="line">
-            <a:avLst/>
-          </a:prstGeom>
-          <a:noFill/>
-          <a:ln w="15875">
-            <a:solidFill>
-              <a:srgbClr val="94A3B8"/>
-            </a:solidFill>
-            <a:prstDash val="solid"/>
-            <a:tailEnd type="triangle"/>
-          </a:ln>
-        </p:spPr>
-      </p:sp>
-      <p:sp>
-        <p:nvSpPr>
-          <p:cNvPr id="13" name="Shape 11"/>
-          <p:cNvSpPr/>
-          <p:nvPr/>
-        </p:nvSpPr>
-        <p:spPr>
-          <a:xfrm>
-            <a:off x="457200" y="2103120"/>
-            <a:ext cx="1371600" cy="548640"/>
-          </a:xfrm>
-          <a:prstGeom prst="roundRect">
-            <a:avLst>
-              <a:gd name="adj" fmla="val 10000"/>
-            </a:avLst>
-          </a:prstGeom>
-          <a:solidFill>
-            <a:srgbClr val="1F2A44"/>
-          </a:solidFill>
           <a:ln w="12700">
             <a:solidFill>
-              <a:srgbClr val="1F2A44"/>
+              <a:srgbClr val="22C55E"/>
             </a:solidFill>
-            <a:prstDash val="solid"/>
           </a:ln>
         </p:spPr>
-      </p:sp>
-      <p:sp>
-        <p:nvSpPr>
-          <p:cNvPr id="14" name="Text 12"/>
+        <p:style>
+          <a:lnRef idx="2">
+            <a:schemeClr val="accent1"/>
+          </a:lnRef>
+          <a:fillRef idx="0">
+            <a:schemeClr val="accent1"/>
+          </a:fillRef>
+          <a:effectRef idx="1">
+            <a:schemeClr val="accent1"/>
+          </a:effectRef>
+          <a:fontRef idx="minor">
+            <a:schemeClr val="tx1"/>
+          </a:fontRef>
+        </p:style>
+      </p:cxnSp>
+      <p:sp>
+        <p:nvSpPr>
+          <p:cNvPr id="27" name="TextBox 26"/>
           <p:cNvSpPr txBox="1"/>
           <p:nvPr/>
         </p:nvSpPr>
         <p:spPr>
           <a:xfrm>
-            <a:off x="502920" y="2103120"/>
-            <a:ext cx="1280160" cy="548640"/>
+            <a:off x="3246120" y="3986784"/>
+            <a:ext cx="2743200" cy="182880"/>
           </a:xfrm>
           <a:prstGeom prst="rect">
             <a:avLst/>
           </a:prstGeom>
           <a:noFill/>
-          <a:ln/>
-        </p:spPr>
-        <p:txBody>
-          <a:bodyPr wrap="square" lIns="0" tIns="0" rIns="0" bIns="0" rtlCol="0" anchor="ctr"/>
-          <a:lstStyle/>
-          <a:p>
-            <a:pPr marL="0" indent="0" algn="ctr">
-              <a:buNone/>
-            </a:pPr>
-            <a:r>
-              <a:rPr lang="en-US" sz="1050" b="1" dirty="0">
-                <a:solidFill>
-                  <a:srgbClr val="CBD5E1"/>
-                </a:solidFill>
-                <a:latin typeface="Calibri" pitchFamily="34" charset="0"/>
-                <a:ea typeface="Calibri" pitchFamily="34" charset="-122"/>
-                <a:cs typeface="Calibri" pitchFamily="34" charset="-120"/>
-              </a:rPr>
-              <a:t>Disruption / headline</a:t>
-            </a:r>
-            <a:endParaRPr lang="en-US" sz="1050" dirty="0"/>
-          </a:p>
-        </p:txBody>
-      </p:sp>
-      <p:sp>
-        <p:nvSpPr>
-          <p:cNvPr id="15" name="Shape 13"/>
-          <p:cNvSpPr/>
-          <p:nvPr/>
-        </p:nvSpPr>
-        <p:spPr>
-          <a:xfrm>
-            <a:off x="1865376" y="2377440"/>
-            <a:ext cx="274320" cy="0"/>
-          </a:xfrm>
-          <a:prstGeom prst="line">
+        </p:spPr>
+        <p:txBody>
+          <a:bodyPr wrap="square">
+            <a:spAutoFit/>
+          </a:bodyPr>
+          <a:lstStyle/>
+          <a:p>
+            <a:pPr algn="l"/>
+            <a:r>
+              <a:rPr sz="600" b="0">
+                <a:solidFill>
+                  <a:srgbClr val="64748B"/>
+                </a:solidFill>
+                <a:latin typeface="Arial"/>
+              </a:rPr>
+              <a:t>dashed = after the decision is made</a:t>
+            </a:r>
+          </a:p>
+        </p:txBody>
+      </p:sp>
+      <p:sp>
+        <p:nvSpPr>
+          <p:cNvPr id="28" name="TextBox 27"/>
+          <p:cNvSpPr txBox="1"/>
+          <p:nvPr/>
+        </p:nvSpPr>
+        <p:spPr>
+          <a:xfrm>
+            <a:off x="411480" y="4224528"/>
+            <a:ext cx="8321040" cy="182880"/>
+          </a:xfrm>
+          <a:prstGeom prst="rect">
             <a:avLst/>
           </a:prstGeom>
           <a:noFill/>
-          <a:ln w="15875">
-            <a:solidFill>
-              <a:srgbClr val="94A3B8"/>
-            </a:solidFill>
-            <a:prstDash val="solid"/>
-            <a:tailEnd type="triangle"/>
-          </a:ln>
-        </p:spPr>
-      </p:sp>
-      <p:sp>
-        <p:nvSpPr>
-          <p:cNvPr id="16" name="Shape 14"/>
-          <p:cNvSpPr/>
-          <p:nvPr/>
-        </p:nvSpPr>
-        <p:spPr>
-          <a:xfrm>
-            <a:off x="2171700" y="2103120"/>
-            <a:ext cx="1371600" cy="548640"/>
-          </a:xfrm>
-          <a:prstGeom prst="roundRect">
-            <a:avLst>
-              <a:gd name="adj" fmla="val 10000"/>
-            </a:avLst>
-          </a:prstGeom>
-          <a:solidFill>
-            <a:srgbClr val="0E3A4A"/>
-          </a:solidFill>
-          <a:ln w="12700">
-            <a:solidFill>
-              <a:srgbClr val="0E3A4A"/>
-            </a:solidFill>
-            <a:prstDash val="solid"/>
-          </a:ln>
-        </p:spPr>
-      </p:sp>
-      <p:sp>
-        <p:nvSpPr>
-          <p:cNvPr id="17" name="Text 15"/>
+        </p:spPr>
+        <p:txBody>
+          <a:bodyPr wrap="square">
+            <a:spAutoFit/>
+          </a:bodyPr>
+          <a:lstStyle/>
+          <a:p>
+            <a:pPr algn="l"/>
+            <a:r>
+              <a:rPr sz="800" b="1">
+                <a:solidFill>
+                  <a:srgbClr val="F1F5F9"/>
+                </a:solidFill>
+                <a:latin typeface="Arial"/>
+              </a:rPr>
+              <a:t>Severity, disposition and the clock are computed. Pull the credentials and every number on screen is identical.</a:t>
+            </a:r>
+          </a:p>
+        </p:txBody>
+      </p:sp>
+      <p:sp>
+        <p:nvSpPr>
+          <p:cNvPr id="29" name="TextBox 28"/>
           <p:cNvSpPr txBox="1"/>
           <p:nvPr/>
         </p:nvSpPr>
         <p:spPr>
           <a:xfrm>
-            <a:off x="2217420" y="2103120"/>
-            <a:ext cx="1280160" cy="548640"/>
+            <a:off x="411480" y="4434840"/>
+            <a:ext cx="8321040" cy="182880"/>
           </a:xfrm>
           <a:prstGeom prst="rect">
             <a:avLst/>
           </a:prstGeom>
           <a:noFill/>
-          <a:ln/>
-        </p:spPr>
-        <p:txBody>
-          <a:bodyPr wrap="square" lIns="0" tIns="0" rIns="0" bIns="0" rtlCol="0" anchor="ctr"/>
-          <a:lstStyle/>
-          <a:p>
-            <a:pPr marL="0" indent="0" algn="ctr">
-              <a:buNone/>
-            </a:pPr>
-            <a:r>
-              <a:rPr lang="en-US" sz="1050" b="1" dirty="0">
-                <a:solidFill>
-                  <a:srgbClr val="A5F3FC"/>
-                </a:solidFill>
-                <a:latin typeface="Calibri" pitchFamily="34" charset="0"/>
-                <a:ea typeface="Calibri" pitchFamily="34" charset="-122"/>
-                <a:cs typeface="Calibri" pitchFamily="34" charset="-120"/>
-              </a:rPr>
-              <a:t>Remaining-path impact</a:t>
-            </a:r>
-            <a:endParaRPr lang="en-US" sz="1050" dirty="0"/>
-          </a:p>
-        </p:txBody>
-      </p:sp>
-      <p:sp>
-        <p:nvSpPr>
-          <p:cNvPr id="18" name="Shape 16"/>
-          <p:cNvSpPr/>
-          <p:nvPr/>
-        </p:nvSpPr>
-        <p:spPr>
-          <a:xfrm>
-            <a:off x="3579876" y="2377440"/>
-            <a:ext cx="274320" cy="0"/>
-          </a:xfrm>
-          <a:prstGeom prst="line">
+        </p:spPr>
+        <p:txBody>
+          <a:bodyPr wrap="square">
+            <a:spAutoFit/>
+          </a:bodyPr>
+          <a:lstStyle/>
+          <a:p>
+            <a:pPr algn="l"/>
+            <a:r>
+              <a:rPr sz="750" b="0">
+                <a:solidFill>
+                  <a:srgbClr val="94A3B8"/>
+                </a:solidFill>
+                <a:latin typeface="Arial"/>
+              </a:rPr>
+              <a:t>IBM Bob operates the tower through 12 MCP tools over Streamable HTTP — and is refused when it tries to commit.</a:t>
+            </a:r>
+          </a:p>
+        </p:txBody>
+      </p:sp>
+      <p:sp>
+        <p:nvSpPr>
+          <p:cNvPr id="30" name="TextBox 29"/>
+          <p:cNvSpPr txBox="1"/>
+          <p:nvPr/>
+        </p:nvSpPr>
+        <p:spPr>
+          <a:xfrm>
+            <a:off x="411480" y="4736592"/>
+            <a:ext cx="8321040" cy="182880"/>
+          </a:xfrm>
+          <a:prstGeom prst="rect">
             <a:avLst/>
           </a:prstGeom>
           <a:noFill/>
-          <a:ln w="15875">
-            <a:solidFill>
-              <a:srgbClr val="94A3B8"/>
-            </a:solidFill>
-            <a:prstDash val="solid"/>
-            <a:tailEnd type="triangle"/>
-          </a:ln>
-        </p:spPr>
-      </p:sp>
-      <p:sp>
-        <p:nvSpPr>
-          <p:cNvPr id="19" name="Shape 17"/>
-          <p:cNvSpPr/>
-          <p:nvPr/>
-        </p:nvSpPr>
-        <p:spPr>
-          <a:xfrm>
-            <a:off x="3886200" y="2103120"/>
-            <a:ext cx="1371600" cy="548640"/>
-          </a:xfrm>
-          <a:prstGeom prst="roundRect">
-            <a:avLst>
-              <a:gd name="adj" fmla="val 10000"/>
-            </a:avLst>
-          </a:prstGeom>
-          <a:solidFill>
-            <a:srgbClr val="0E3A4A"/>
-          </a:solidFill>
-          <a:ln w="12700">
-            <a:solidFill>
-              <a:srgbClr val="0E3A4A"/>
-            </a:solidFill>
-            <a:prstDash val="solid"/>
-          </a:ln>
-        </p:spPr>
-      </p:sp>
-      <p:sp>
-        <p:nvSpPr>
-          <p:cNvPr id="20" name="Text 18"/>
-          <p:cNvSpPr txBox="1"/>
-          <p:nvPr/>
-        </p:nvSpPr>
-        <p:spPr>
-          <a:xfrm>
-            <a:off x="3931920" y="2103120"/>
-            <a:ext cx="1280160" cy="548640"/>
-          </a:xfrm>
-          <a:prstGeom prst="rect">
-            <a:avLst/>
-          </a:prstGeom>
-          <a:noFill/>
-          <a:ln/>
-        </p:spPr>
-        <p:txBody>
-          <a:bodyPr wrap="square" lIns="0" tIns="0" rIns="0" bIns="0" rtlCol="0" anchor="ctr"/>
-          <a:lstStyle/>
-          <a:p>
-            <a:pPr marL="0" indent="0" algn="ctr">
-              <a:buNone/>
-            </a:pPr>
-            <a:r>
-              <a:rPr lang="en-US" sz="1050" b="1" dirty="0">
-                <a:solidFill>
-                  <a:srgbClr val="A5F3FC"/>
-                </a:solidFill>
-                <a:latin typeface="Calibri" pitchFamily="34" charset="0"/>
-                <a:ea typeface="Calibri" pitchFamily="34" charset="-122"/>
-                <a:cs typeface="Calibri" pitchFamily="34" charset="-120"/>
-              </a:rPr>
-              <a:t>Viability clock</a:t>
-            </a:r>
-            <a:endParaRPr lang="en-US" sz="1050" dirty="0"/>
-          </a:p>
-        </p:txBody>
-      </p:sp>
-      <p:sp>
-        <p:nvSpPr>
-          <p:cNvPr id="21" name="Shape 19"/>
-          <p:cNvSpPr/>
-          <p:nvPr/>
-        </p:nvSpPr>
-        <p:spPr>
-          <a:xfrm>
-            <a:off x="5294376" y="2377440"/>
-            <a:ext cx="274320" cy="0"/>
-          </a:xfrm>
-          <a:prstGeom prst="line">
-            <a:avLst/>
-          </a:prstGeom>
-          <a:noFill/>
-          <a:ln w="15875">
-            <a:solidFill>
-              <a:srgbClr val="94A3B8"/>
-            </a:solidFill>
-            <a:prstDash val="solid"/>
-            <a:tailEnd type="triangle"/>
-          </a:ln>
-        </p:spPr>
-      </p:sp>
-      <p:sp>
-        <p:nvSpPr>
-          <p:cNvPr id="22" name="Shape 20"/>
-          <p:cNvSpPr/>
-          <p:nvPr/>
-        </p:nvSpPr>
-        <p:spPr>
-          <a:xfrm>
-            <a:off x="5600700" y="2103120"/>
-            <a:ext cx="1371600" cy="548640"/>
-          </a:xfrm>
-          <a:prstGeom prst="roundRect">
-            <a:avLst>
-              <a:gd name="adj" fmla="val 10000"/>
-            </a:avLst>
-          </a:prstGeom>
-          <a:solidFill>
-            <a:srgbClr val="0E3A4A"/>
-          </a:solidFill>
-          <a:ln w="12700">
-            <a:solidFill>
-              <a:srgbClr val="0E3A4A"/>
-            </a:solidFill>
-            <a:prstDash val="solid"/>
-          </a:ln>
-        </p:spPr>
-      </p:sp>
-      <p:sp>
-        <p:nvSpPr>
-          <p:cNvPr id="23" name="Text 21"/>
-          <p:cNvSpPr txBox="1"/>
-          <p:nvPr/>
-        </p:nvSpPr>
-        <p:spPr>
-          <a:xfrm>
-            <a:off x="5646420" y="2103120"/>
-            <a:ext cx="1280160" cy="548640"/>
-          </a:xfrm>
-          <a:prstGeom prst="rect">
-            <a:avLst/>
-          </a:prstGeom>
-          <a:noFill/>
-          <a:ln/>
-        </p:spPr>
-        <p:txBody>
-          <a:bodyPr wrap="square" lIns="0" tIns="0" rIns="0" bIns="0" rtlCol="0" anchor="ctr"/>
-          <a:lstStyle/>
-          <a:p>
-            <a:pPr marL="0" indent="0" algn="ctr">
-              <a:buNone/>
-            </a:pPr>
-            <a:r>
-              <a:rPr lang="en-US" sz="1050" b="1" dirty="0">
-                <a:solidFill>
-                  <a:srgbClr val="A5F3FC"/>
-                </a:solidFill>
-                <a:latin typeface="Calibri" pitchFamily="34" charset="0"/>
-                <a:ea typeface="Calibri" pitchFamily="34" charset="-122"/>
-                <a:cs typeface="Calibri" pitchFamily="34" charset="-120"/>
-              </a:rPr>
-              <a:t>Graph router + landed cost</a:t>
-            </a:r>
-            <a:endParaRPr lang="en-US" sz="1050" dirty="0"/>
-          </a:p>
-        </p:txBody>
-      </p:sp>
-      <p:sp>
-        <p:nvSpPr>
-          <p:cNvPr id="24" name="Shape 22"/>
-          <p:cNvSpPr/>
-          <p:nvPr/>
-        </p:nvSpPr>
-        <p:spPr>
-          <a:xfrm>
-            <a:off x="7008876" y="2377440"/>
-            <a:ext cx="274320" cy="0"/>
-          </a:xfrm>
-          <a:prstGeom prst="line">
-            <a:avLst/>
-          </a:prstGeom>
-          <a:noFill/>
-          <a:ln w="15875">
-            <a:solidFill>
-              <a:srgbClr val="94A3B8"/>
-            </a:solidFill>
-            <a:prstDash val="solid"/>
-            <a:tailEnd type="triangle"/>
-          </a:ln>
-        </p:spPr>
-      </p:sp>
-      <p:sp>
-        <p:nvSpPr>
-          <p:cNvPr id="25" name="Shape 23"/>
-          <p:cNvSpPr/>
-          <p:nvPr/>
-        </p:nvSpPr>
-        <p:spPr>
-          <a:xfrm>
-            <a:off x="7315200" y="2103120"/>
-            <a:ext cx="1371600" cy="548640"/>
-          </a:xfrm>
-          <a:prstGeom prst="roundRect">
-            <a:avLst>
-              <a:gd name="adj" fmla="val 10000"/>
-            </a:avLst>
-          </a:prstGeom>
-          <a:solidFill>
-            <a:srgbClr val="0E3A4A"/>
-          </a:solidFill>
-          <a:ln w="12700">
-            <a:solidFill>
-              <a:srgbClr val="0E3A4A"/>
-            </a:solidFill>
-            <a:prstDash val="solid"/>
-          </a:ln>
-        </p:spPr>
-      </p:sp>
-      <p:sp>
-        <p:nvSpPr>
-          <p:cNvPr id="26" name="Text 24"/>
-          <p:cNvSpPr txBox="1"/>
-          <p:nvPr/>
-        </p:nvSpPr>
-        <p:spPr>
-          <a:xfrm>
-            <a:off x="7360920" y="2103120"/>
-            <a:ext cx="1280160" cy="548640"/>
-          </a:xfrm>
-          <a:prstGeom prst="rect">
-            <a:avLst/>
-          </a:prstGeom>
-          <a:noFill/>
-          <a:ln/>
-        </p:spPr>
-        <p:txBody>
-          <a:bodyPr wrap="square" lIns="0" tIns="0" rIns="0" bIns="0" rtlCol="0" anchor="ctr"/>
-          <a:lstStyle/>
-          <a:p>
-            <a:pPr marL="0" indent="0" algn="ctr">
-              <a:buNone/>
-            </a:pPr>
-            <a:r>
-              <a:rPr lang="en-US" sz="1050" b="1" dirty="0">
-                <a:solidFill>
-                  <a:srgbClr val="A5F3FC"/>
-                </a:solidFill>
-                <a:latin typeface="Calibri" pitchFamily="34" charset="0"/>
-                <a:ea typeface="Calibri" pitchFamily="34" charset="-122"/>
-                <a:cs typeface="Calibri" pitchFamily="34" charset="-120"/>
-              </a:rPr>
-              <a:t>Fleet matcher (0–100)</a:t>
-            </a:r>
-            <a:endParaRPr lang="en-US" sz="1050" dirty="0"/>
-          </a:p>
-        </p:txBody>
-      </p:sp>
-      <p:sp>
-        <p:nvSpPr>
-          <p:cNvPr id="27" name="Shape 25"/>
-          <p:cNvSpPr/>
-          <p:nvPr/>
-        </p:nvSpPr>
-        <p:spPr>
-          <a:xfrm>
-            <a:off x="457200" y="2926080"/>
-            <a:ext cx="1371600" cy="548640"/>
-          </a:xfrm>
-          <a:prstGeom prst="roundRect">
-            <a:avLst>
-              <a:gd name="adj" fmla="val 10000"/>
-            </a:avLst>
-          </a:prstGeom>
-          <a:solidFill>
-            <a:srgbClr val="1F2A44"/>
-          </a:solidFill>
-          <a:ln w="12700">
-            <a:solidFill>
-              <a:srgbClr val="1F2A44"/>
-            </a:solidFill>
-            <a:prstDash val="solid"/>
-          </a:ln>
-        </p:spPr>
-      </p:sp>
-      <p:sp>
-        <p:nvSpPr>
-          <p:cNvPr id="28" name="Text 26"/>
-          <p:cNvSpPr txBox="1"/>
-          <p:nvPr/>
-        </p:nvSpPr>
-        <p:spPr>
-          <a:xfrm>
-            <a:off x="502920" y="2926080"/>
-            <a:ext cx="1280160" cy="548640"/>
-          </a:xfrm>
-          <a:prstGeom prst="rect">
-            <a:avLst/>
-          </a:prstGeom>
-          <a:noFill/>
-          <a:ln/>
-        </p:spPr>
-        <p:txBody>
-          <a:bodyPr wrap="square" lIns="0" tIns="0" rIns="0" bIns="0" rtlCol="0" anchor="ctr"/>
-          <a:lstStyle/>
-          <a:p>
-            <a:pPr marL="0" indent="0" algn="ctr">
-              <a:buNone/>
-            </a:pPr>
-            <a:r>
-              <a:rPr lang="en-US" sz="1050" b="1" dirty="0">
-                <a:solidFill>
-                  <a:srgbClr val="CBD5E1"/>
-                </a:solidFill>
-                <a:latin typeface="Calibri" pitchFamily="34" charset="0"/>
-                <a:ea typeface="Calibri" pitchFamily="34" charset="-122"/>
-                <a:cs typeface="Calibri" pitchFamily="34" charset="-120"/>
-              </a:rPr>
-              <a:t>IBM Bob</a:t>
-            </a:r>
-            <a:endParaRPr lang="en-US" sz="1050" dirty="0"/>
-          </a:p>
-        </p:txBody>
-      </p:sp>
-      <p:sp>
-        <p:nvSpPr>
-          <p:cNvPr id="29" name="Shape 27"/>
-          <p:cNvSpPr/>
-          <p:nvPr/>
-        </p:nvSpPr>
-        <p:spPr>
-          <a:xfrm>
-            <a:off x="2171700" y="2926080"/>
-            <a:ext cx="1371600" cy="548640"/>
-          </a:xfrm>
-          <a:prstGeom prst="roundRect">
-            <a:avLst>
-              <a:gd name="adj" fmla="val 10000"/>
-            </a:avLst>
-          </a:prstGeom>
-          <a:solidFill>
-            <a:srgbClr val="2A2560"/>
-          </a:solidFill>
-          <a:ln w="12700">
-            <a:solidFill>
-              <a:srgbClr val="2A2560"/>
-            </a:solidFill>
-            <a:prstDash val="solid"/>
-          </a:ln>
-        </p:spPr>
-      </p:sp>
-      <p:sp>
-        <p:nvSpPr>
-          <p:cNvPr id="30" name="Text 28"/>
-          <p:cNvSpPr txBox="1"/>
-          <p:nvPr/>
-        </p:nvSpPr>
-        <p:spPr>
-          <a:xfrm>
-            <a:off x="2217420" y="2926080"/>
-            <a:ext cx="1280160" cy="548640"/>
-          </a:xfrm>
-          <a:prstGeom prst="rect">
-            <a:avLst/>
-          </a:prstGeom>
-          <a:noFill/>
-          <a:ln/>
-        </p:spPr>
-        <p:txBody>
-          <a:bodyPr wrap="square" lIns="0" tIns="0" rIns="0" bIns="0" rtlCol="0" anchor="ctr"/>
-          <a:lstStyle/>
-          <a:p>
-            <a:pPr marL="0" indent="0" algn="ctr">
-              <a:buNone/>
-            </a:pPr>
-            <a:r>
-              <a:rPr lang="en-US" sz="1050" b="1" dirty="0">
-                <a:solidFill>
-                  <a:srgbClr val="DDD6FE"/>
-                </a:solidFill>
-                <a:latin typeface="Calibri" pitchFamily="34" charset="0"/>
-                <a:ea typeface="Calibri" pitchFamily="34" charset="-122"/>
-                <a:cs typeface="Calibri" pitchFamily="34" charset="-120"/>
-              </a:rPr>
-              <a:t>MCP over HTTP · 12 tools · commits refused</a:t>
-            </a:r>
-            <a:endParaRPr lang="en-US" sz="1050" dirty="0"/>
-          </a:p>
-        </p:txBody>
-      </p:sp>
-      <p:sp>
-        <p:nvSpPr>
-          <p:cNvPr id="31" name="Shape 29"/>
-          <p:cNvSpPr/>
-          <p:nvPr/>
-        </p:nvSpPr>
-        <p:spPr>
-          <a:xfrm>
-            <a:off x="1865376" y="3200400"/>
-            <a:ext cx="274320" cy="0"/>
-          </a:xfrm>
-          <a:prstGeom prst="line">
-            <a:avLst/>
-          </a:prstGeom>
-          <a:noFill/>
-          <a:ln w="15875">
-            <a:solidFill>
-              <a:srgbClr val="94A3B8"/>
-            </a:solidFill>
-            <a:prstDash val="solid"/>
-            <a:tailEnd type="triangle"/>
-          </a:ln>
-        </p:spPr>
-      </p:sp>
-      <p:sp>
-        <p:nvSpPr>
-          <p:cNvPr id="32" name="Shape 30"/>
-          <p:cNvSpPr/>
-          <p:nvPr/>
-        </p:nvSpPr>
-        <p:spPr>
-          <a:xfrm>
-            <a:off x="7315200" y="2926080"/>
-            <a:ext cx="1371600" cy="548640"/>
-          </a:xfrm>
-          <a:prstGeom prst="roundRect">
-            <a:avLst>
-              <a:gd name="adj" fmla="val 10000"/>
-            </a:avLst>
-          </a:prstGeom>
-          <a:solidFill>
-            <a:srgbClr val="2A2560"/>
-          </a:solidFill>
-          <a:ln w="12700">
-            <a:solidFill>
-              <a:srgbClr val="2A2560"/>
-            </a:solidFill>
-            <a:prstDash val="solid"/>
-          </a:ln>
-        </p:spPr>
-      </p:sp>
-      <p:sp>
-        <p:nvSpPr>
-          <p:cNvPr id="33" name="Text 31"/>
-          <p:cNvSpPr txBox="1"/>
-          <p:nvPr/>
-        </p:nvSpPr>
-        <p:spPr>
-          <a:xfrm>
-            <a:off x="7360920" y="2926080"/>
-            <a:ext cx="1280160" cy="548640"/>
-          </a:xfrm>
-          <a:prstGeom prst="rect">
-            <a:avLst/>
-          </a:prstGeom>
-          <a:noFill/>
-          <a:ln/>
-        </p:spPr>
-        <p:txBody>
-          <a:bodyPr wrap="square" lIns="0" tIns="0" rIns="0" bIns="0" rtlCol="0" anchor="ctr"/>
-          <a:lstStyle/>
-          <a:p>
-            <a:pPr marL="0" indent="0" algn="ctr">
-              <a:buNone/>
-            </a:pPr>
-            <a:r>
-              <a:rPr lang="en-US" sz="1050" b="1" dirty="0">
-                <a:solidFill>
-                  <a:srgbClr val="DDD6FE"/>
-                </a:solidFill>
-                <a:latin typeface="Calibri" pitchFamily="34" charset="0"/>
-                <a:ea typeface="Calibri" pitchFamily="34" charset="-122"/>
-                <a:cs typeface="Calibri" pitchFamily="34" charset="-120"/>
-              </a:rPr>
-              <a:t>Hash-chained audit</a:t>
-            </a:r>
-            <a:endParaRPr lang="en-US" sz="1050" dirty="0"/>
-          </a:p>
-        </p:txBody>
-      </p:sp>
-      <p:sp>
-        <p:nvSpPr>
-          <p:cNvPr id="34" name="Shape 32"/>
-          <p:cNvSpPr/>
-          <p:nvPr/>
-        </p:nvSpPr>
-        <p:spPr>
-          <a:xfrm>
-            <a:off x="8001000" y="2670048"/>
-            <a:ext cx="0" cy="256032"/>
-          </a:xfrm>
-          <a:prstGeom prst="line">
-            <a:avLst/>
-          </a:prstGeom>
-          <a:noFill/>
-          <a:ln w="15875">
-            <a:solidFill>
-              <a:srgbClr val="94A3B8"/>
-            </a:solidFill>
-            <a:prstDash val="solid"/>
-            <a:tailEnd type="triangle"/>
-          </a:ln>
-        </p:spPr>
-      </p:sp>
-      <p:sp>
-        <p:nvSpPr>
-          <p:cNvPr id="35" name="Shape 33"/>
-          <p:cNvSpPr/>
-          <p:nvPr/>
-        </p:nvSpPr>
-        <p:spPr>
-          <a:xfrm>
-            <a:off x="457200" y="3749040"/>
-            <a:ext cx="5394960" cy="868680"/>
-          </a:xfrm>
-          <a:prstGeom prst="roundRect">
-            <a:avLst>
-              <a:gd name="adj" fmla="val 8421"/>
-            </a:avLst>
-          </a:prstGeom>
-          <a:solidFill>
-            <a:srgbClr val="14213D"/>
-          </a:solidFill>
-          <a:ln w="12700">
-            <a:solidFill>
-              <a:srgbClr val="14213D"/>
-            </a:solidFill>
-            <a:prstDash val="solid"/>
-          </a:ln>
-        </p:spPr>
-      </p:sp>
-      <p:sp>
-        <p:nvSpPr>
-          <p:cNvPr id="36" name="Text 34"/>
-          <p:cNvSpPr txBox="1"/>
-          <p:nvPr/>
-        </p:nvSpPr>
-        <p:spPr>
-          <a:xfrm>
-            <a:off x="685800" y="3840480"/>
-            <a:ext cx="5029200" cy="365760"/>
-          </a:xfrm>
-          <a:prstGeom prst="rect">
-            <a:avLst/>
-          </a:prstGeom>
-          <a:noFill/>
-          <a:ln/>
-        </p:spPr>
-        <p:txBody>
-          <a:bodyPr wrap="square" lIns="0" tIns="0" rIns="0" bIns="0" rtlCol="0" anchor="t"/>
-          <a:lstStyle/>
-          <a:p>
-            <a:pPr marL="0" indent="0">
-              <a:buNone/>
-            </a:pPr>
-            <a:r>
-              <a:rPr lang="en-US" sz="1600" b="1" dirty="0">
-                <a:solidFill>
-                  <a:srgbClr val="F1F5F9"/>
-                </a:solidFill>
-                <a:latin typeface="Calibri" pitchFamily="34" charset="0"/>
-                <a:ea typeface="Calibri" pitchFamily="34" charset="-122"/>
-                <a:cs typeface="Calibri" pitchFamily="34" charset="-120"/>
-              </a:rPr>
-              <a:t>Engines are pure functions with an injected clock — 165 tests, no I/O, no wall-clock reads.</a:t>
-            </a:r>
-            <a:endParaRPr lang="en-US" sz="1600" dirty="0"/>
-          </a:p>
-        </p:txBody>
-      </p:sp>
-      <p:sp>
-        <p:nvSpPr>
-          <p:cNvPr id="37" name="Text 35"/>
-          <p:cNvSpPr txBox="1"/>
-          <p:nvPr/>
-        </p:nvSpPr>
-        <p:spPr>
-          <a:xfrm>
-            <a:off x="685800" y="4206240"/>
-            <a:ext cx="5029200" cy="274320"/>
-          </a:xfrm>
-          <a:prstGeom prst="rect">
-            <a:avLst/>
-          </a:prstGeom>
-          <a:noFill/>
-          <a:ln/>
-        </p:spPr>
-        <p:txBody>
-          <a:bodyPr wrap="square" lIns="0" tIns="0" rIns="0" bIns="0" rtlCol="0" anchor="t"/>
-          <a:lstStyle/>
-          <a:p>
-            <a:pPr marL="0" indent="0">
-              <a:buNone/>
-            </a:pPr>
-            <a:r>
-              <a:rPr lang="en-US" sz="1200" dirty="0">
-                <a:solidFill>
-                  <a:srgbClr val="94A3B8"/>
-                </a:solidFill>
-                <a:latin typeface="Calibri" pitchFamily="34" charset="0"/>
-                <a:ea typeface="Calibri" pitchFamily="34" charset="-122"/>
-                <a:cs typeface="Calibri" pitchFamily="34" charset="-120"/>
-              </a:rPr>
-              <a:t>The model never sets a severity, a clock value or a disposition.</a:t>
-            </a:r>
-            <a:endParaRPr lang="en-US" sz="1200" dirty="0"/>
-          </a:p>
-        </p:txBody>
-      </p:sp>
-      <p:sp>
-        <p:nvSpPr>
-          <p:cNvPr id="38" name="Shape 36"/>
-          <p:cNvSpPr/>
-          <p:nvPr/>
-        </p:nvSpPr>
-        <p:spPr>
-          <a:xfrm>
-            <a:off x="6217920" y="3794760"/>
-            <a:ext cx="201168" cy="182880"/>
-          </a:xfrm>
-          <a:prstGeom prst="roundRect">
-            <a:avLst>
-              <a:gd name="adj" fmla="val 20000"/>
-            </a:avLst>
-          </a:prstGeom>
-          <a:solidFill>
-            <a:srgbClr val="1F2A44"/>
-          </a:solidFill>
-          <a:ln w="12700">
-            <a:solidFill>
-              <a:srgbClr val="334155"/>
-            </a:solidFill>
-            <a:prstDash val="solid"/>
-          </a:ln>
-        </p:spPr>
-      </p:sp>
-      <p:sp>
-        <p:nvSpPr>
-          <p:cNvPr id="39" name="Text 37"/>
-          <p:cNvSpPr txBox="1"/>
-          <p:nvPr/>
-        </p:nvSpPr>
-        <p:spPr>
-          <a:xfrm>
-            <a:off x="6510528" y="3767328"/>
-            <a:ext cx="2103120" cy="237744"/>
-          </a:xfrm>
-          <a:prstGeom prst="rect">
-            <a:avLst/>
-          </a:prstGeom>
-          <a:noFill/>
-          <a:ln/>
-        </p:spPr>
-        <p:txBody>
-          <a:bodyPr wrap="square" lIns="0" tIns="0" rIns="0" bIns="0" rtlCol="0" anchor="ctr"/>
-          <a:lstStyle/>
-          <a:p>
-            <a:pPr marL="0" indent="0">
-              <a:buNone/>
-            </a:pPr>
-            <a:r>
-              <a:rPr lang="en-US" sz="1100" dirty="0">
-                <a:solidFill>
-                  <a:srgbClr val="CBD5E1"/>
-                </a:solidFill>
-                <a:latin typeface="Calibri" pitchFamily="34" charset="0"/>
-                <a:ea typeface="Calibri" pitchFamily="34" charset="-122"/>
-                <a:cs typeface="Calibri" pitchFamily="34" charset="-120"/>
-              </a:rPr>
-              <a:t>Input</a:t>
-            </a:r>
-            <a:endParaRPr lang="en-US" sz="1100" dirty="0"/>
-          </a:p>
-        </p:txBody>
-      </p:sp>
-      <p:sp>
-        <p:nvSpPr>
-          <p:cNvPr id="40" name="Shape 38"/>
-          <p:cNvSpPr/>
-          <p:nvPr/>
-        </p:nvSpPr>
-        <p:spPr>
-          <a:xfrm>
-            <a:off x="6217920" y="4069080"/>
-            <a:ext cx="201168" cy="182880"/>
-          </a:xfrm>
-          <a:prstGeom prst="roundRect">
-            <a:avLst>
-              <a:gd name="adj" fmla="val 20000"/>
-            </a:avLst>
-          </a:prstGeom>
-          <a:solidFill>
-            <a:srgbClr val="0E3A4A"/>
-          </a:solidFill>
-          <a:ln w="12700">
-            <a:solidFill>
-              <a:srgbClr val="0E3A4A"/>
-            </a:solidFill>
-            <a:prstDash val="solid"/>
-          </a:ln>
-        </p:spPr>
-      </p:sp>
-      <p:sp>
-        <p:nvSpPr>
-          <p:cNvPr id="41" name="Text 39"/>
-          <p:cNvSpPr txBox="1"/>
-          <p:nvPr/>
-        </p:nvSpPr>
-        <p:spPr>
-          <a:xfrm>
-            <a:off x="6510528" y="4041648"/>
-            <a:ext cx="2103120" cy="237744"/>
-          </a:xfrm>
-          <a:prstGeom prst="rect">
-            <a:avLst/>
-          </a:prstGeom>
-          <a:noFill/>
-          <a:ln/>
-        </p:spPr>
-        <p:txBody>
-          <a:bodyPr wrap="square" lIns="0" tIns="0" rIns="0" bIns="0" rtlCol="0" anchor="ctr"/>
-          <a:lstStyle/>
-          <a:p>
-            <a:pPr marL="0" indent="0">
-              <a:buNone/>
-            </a:pPr>
-            <a:r>
-              <a:rPr lang="en-US" sz="1100" dirty="0">
-                <a:solidFill>
-                  <a:srgbClr val="CBD5E1"/>
-                </a:solidFill>
-                <a:latin typeface="Calibri" pitchFamily="34" charset="0"/>
-                <a:ea typeface="Calibri" pitchFamily="34" charset="-122"/>
-                <a:cs typeface="Calibri" pitchFamily="34" charset="-120"/>
-              </a:rPr>
-              <a:t>Deterministic engine</a:t>
-            </a:r>
-            <a:endParaRPr lang="en-US" sz="1100" dirty="0"/>
-          </a:p>
-        </p:txBody>
-      </p:sp>
-      <p:sp>
-        <p:nvSpPr>
-          <p:cNvPr id="42" name="Shape 40"/>
-          <p:cNvSpPr/>
-          <p:nvPr/>
-        </p:nvSpPr>
-        <p:spPr>
-          <a:xfrm>
-            <a:off x="6217920" y="4343400"/>
-            <a:ext cx="201168" cy="182880"/>
-          </a:xfrm>
-          <a:prstGeom prst="roundRect">
-            <a:avLst>
-              <a:gd name="adj" fmla="val 20000"/>
-            </a:avLst>
-          </a:prstGeom>
-          <a:solidFill>
-            <a:srgbClr val="2A2560"/>
-          </a:solidFill>
-          <a:ln w="12700">
-            <a:solidFill>
-              <a:srgbClr val="2A2560"/>
-            </a:solidFill>
-            <a:prstDash val="solid"/>
-          </a:ln>
-        </p:spPr>
-      </p:sp>
-      <p:sp>
-        <p:nvSpPr>
-          <p:cNvPr id="43" name="Text 41"/>
-          <p:cNvSpPr txBox="1"/>
-          <p:nvPr/>
-        </p:nvSpPr>
-        <p:spPr>
-          <a:xfrm>
-            <a:off x="6510528" y="4315968"/>
-            <a:ext cx="2103120" cy="237744"/>
-          </a:xfrm>
-          <a:prstGeom prst="rect">
-            <a:avLst/>
-          </a:prstGeom>
-          <a:noFill/>
-          <a:ln/>
-        </p:spPr>
-        <p:txBody>
-          <a:bodyPr wrap="square" lIns="0" tIns="0" rIns="0" bIns="0" rtlCol="0" anchor="ctr"/>
-          <a:lstStyle/>
-          <a:p>
-            <a:pPr marL="0" indent="0">
-              <a:buNone/>
-            </a:pPr>
-            <a:r>
-              <a:rPr lang="en-US" sz="1100" dirty="0">
-                <a:solidFill>
-                  <a:srgbClr val="CBD5E1"/>
-                </a:solidFill>
-                <a:latin typeface="Calibri" pitchFamily="34" charset="0"/>
-                <a:ea typeface="Calibri" pitchFamily="34" charset="-122"/>
-                <a:cs typeface="Calibri" pitchFamily="34" charset="-120"/>
-              </a:rPr>
-              <a:t>watsonx.ai / AI layer</a:t>
-            </a:r>
-            <a:endParaRPr lang="en-US" sz="1100" dirty="0"/>
-          </a:p>
-        </p:txBody>
-      </p:sp>
-      <p:sp>
-        <p:nvSpPr>
-          <p:cNvPr id="44" name="Text 42"/>
-          <p:cNvSpPr txBox="1"/>
-          <p:nvPr/>
-        </p:nvSpPr>
-        <p:spPr>
-          <a:xfrm>
-            <a:off x="457200" y="4754880"/>
-            <a:ext cx="6858000" cy="228600"/>
-          </a:xfrm>
-          <a:prstGeom prst="rect">
-            <a:avLst/>
-          </a:prstGeom>
-          <a:noFill/>
-          <a:ln/>
-        </p:spPr>
-        <p:txBody>
-          <a:bodyPr wrap="square" lIns="0" tIns="0" rIns="0" bIns="0" rtlCol="0" anchor="t"/>
-          <a:lstStyle/>
-          <a:p>
-            <a:pPr marL="0" indent="0">
-              <a:buNone/>
-            </a:pPr>
-            <a:r>
-              <a:rPr lang="en-US" sz="950" dirty="0">
-                <a:solidFill>
-                  <a:srgbClr val="94A3B8"/>
-                </a:solidFill>
-                <a:latin typeface="Calibri" pitchFamily="34" charset="0"/>
-                <a:ea typeface="Calibri" pitchFamily="34" charset="-122"/>
-                <a:cs typeface="Calibri" pitchFamily="34" charset="-120"/>
+        </p:spPr>
+        <p:txBody>
+          <a:bodyPr wrap="square">
+            <a:spAutoFit/>
+          </a:bodyPr>
+          <a:lstStyle/>
+          <a:p>
+            <a:pPr algn="l"/>
+            <a:r>
+              <a:rPr sz="650" b="0">
+                <a:solidFill>
+                  <a:srgbClr val="64748B"/>
+                </a:solidFill>
+                <a:latin typeface="Arial"/>
               </a:rPr>
               <a:t>Next.js 16 · React 19 · Express 5 · Socket.IO · MongoDB 7 · @modelcontextprotocol/sdk · watsonx.ai</a:t>
             </a:r>
-            <a:endParaRPr lang="en-US" sz="950" dirty="0"/>
           </a:p>
         </p:txBody>
       </p:sp>

</xml_diff>

<commit_message>
docs(presentation): deck updates from the team
Co-Authored-By: Claude Opus 5 (1M context) <noreply@anthropic.com>
</commit_message>
<xml_diff>
--- a/presentation/slides.pptx
+++ b/presentation/slides.pptx
@@ -4,16 +4,16 @@
   <p:sldMasterIdLst>
     <p:sldMasterId id="2147483648" r:id="rId1"/>
   </p:sldMasterIdLst>
+  <p:notesMasterIdLst>
+    <p:notesMasterId r:id="rId6"/>
+  </p:notesMasterIdLst>
   <p:sldIdLst>
     <p:sldId id="256" r:id="rId2"/>
     <p:sldId id="257" r:id="rId3"/>
     <p:sldId id="258" r:id="rId4"/>
     <p:sldId id="259" r:id="rId5"/>
   </p:sldIdLst>
-  <p:notesMasterIdLst>
-    <p:notesMasterId r:id="rId10"/>
-  </p:notesMasterIdLst>
-  <p:sldSz cx="9144000" cy="5143500"/>
+  <p:sldSz cx="9144000" cy="5143500" type="screen16x9"/>
   <p:notesSz cx="5143500" cy="9144000"/>
   <p:defaultTextStyle>
     <a:lvl1pPr marL="0" algn="l" defTabSz="914400" rtl="0" eaLnBrk="1" latinLnBrk="0" hangingPunct="1">
@@ -107,6 +107,11 @@
       </a:defRPr>
     </a:lvl9pPr>
   </p:defaultTextStyle>
+  <p:extLst>
+    <p:ext uri="{EFAFB233-063F-42B5-8137-9DF3F51BA10A}">
+      <p15:sldGuideLst xmlns:p15="http://schemas.microsoft.com/office/powerpoint/2012/main"/>
+    </p:ext>
+  </p:extLst>
 </p:presentation>
 </file>
 
@@ -132,234 +137,10 @@
           <a:chExt cx="0" cy="0"/>
         </a:xfrm>
       </p:grpSpPr>
-      <p:sp>
-        <p:nvSpPr>
-          <p:cNvPr id="2" name="Header Placeholder 1"/>
-          <p:cNvSpPr>
-            <a:spLocks noGrp="1"/>
-          </p:cNvSpPr>
-          <p:nvPr>
-            <p:ph type="hdr" sz="quarter"/>
-          </p:nvPr>
-        </p:nvSpPr>
-        <p:spPr>
-          <a:xfrm>
-            <a:off x="0" y="0"/>
-            <a:ext cx="2971800" cy="458788"/>
-          </a:xfrm>
-          <a:prstGeom prst="rect">
-            <a:avLst/>
-          </a:prstGeom>
-        </p:spPr>
-        <p:txBody>
-          <a:bodyPr vert="horz" lIns="91440" tIns="45720" rIns="91440" bIns="45720" rtlCol="0"/>
-          <a:lstStyle>
-            <a:lvl1pPr algn="l">
-              <a:defRPr sz="1200"/>
-            </a:lvl1pPr>
-          </a:lstStyle>
-          <a:p>
-            <a:endParaRPr lang="en-US"/>
-          </a:p>
-        </p:txBody>
-      </p:sp>
-      <p:sp>
-        <p:nvSpPr>
-          <p:cNvPr id="3" name="Date Placeholder 2"/>
-          <p:cNvSpPr>
-            <a:spLocks noGrp="1"/>
-          </p:cNvSpPr>
-          <p:nvPr>
-            <p:ph type="dt" idx="1"/>
-          </p:nvPr>
-        </p:nvSpPr>
-        <p:spPr>
-          <a:xfrm>
-            <a:off x="3884613" y="0"/>
-            <a:ext cx="2971800" cy="458788"/>
-          </a:xfrm>
-          <a:prstGeom prst="rect">
-            <a:avLst/>
-          </a:prstGeom>
-        </p:spPr>
-        <p:txBody>
-          <a:bodyPr vert="horz" lIns="91440" tIns="45720" rIns="91440" bIns="45720" rtlCol="0"/>
-          <a:lstStyle>
-            <a:lvl1pPr algn="r">
-              <a:defRPr sz="1200"/>
-            </a:lvl1pPr>
-          </a:lstStyle>
-          <a:p>
-            <a:fld id="{5282F153-3F37-0F45-9E97-73ACFA13230C}" type="datetimeFigureOut">
-              <a:rPr lang="en-US"/>
-              <a:t>7/23/19</a:t>
-            </a:fld>
-            <a:endParaRPr lang="en-US"/>
-          </a:p>
-        </p:txBody>
-      </p:sp>
-      <p:sp>
-        <p:nvSpPr>
-          <p:cNvPr id="4" name="Slide Image Placeholder 3"/>
-          <p:cNvSpPr>
-            <a:spLocks noGrp="1" noRot="1" noChangeAspect="1"/>
-          </p:cNvSpPr>
-          <p:nvPr>
-            <p:ph type="sldImg" idx="2"/>
-          </p:nvPr>
-        </p:nvSpPr>
-        <p:spPr>
-          <a:xfrm>
-            <a:off x="685800" y="1143000"/>
-            <a:ext cx="5486400" cy="3086100"/>
-          </a:xfrm>
-          <a:prstGeom prst="rect">
-            <a:avLst/>
-          </a:prstGeom>
-          <a:noFill/>
-          <a:ln w="12700">
-            <a:solidFill>
-              <a:prstClr val="black"/>
-            </a:solidFill>
-          </a:ln>
-        </p:spPr>
-        <p:txBody>
-          <a:bodyPr vert="horz" lIns="91440" tIns="45720" rIns="91440" bIns="45720" rtlCol="0" anchor="ctr"/>
-          <a:lstStyle/>
-          <a:p>
-            <a:endParaRPr lang="en-US"/>
-          </a:p>
-        </p:txBody>
-      </p:sp>
-      <p:sp>
-        <p:nvSpPr>
-          <p:cNvPr id="5" name="Notes Placeholder 4"/>
-          <p:cNvSpPr>
-            <a:spLocks noGrp="1"/>
-          </p:cNvSpPr>
-          <p:nvPr>
-            <p:ph type="body" sz="quarter" idx="3"/>
-          </p:nvPr>
-        </p:nvSpPr>
-        <p:spPr>
-          <a:xfrm>
-            <a:off x="685800" y="4400550"/>
-            <a:ext cx="5486400" cy="3600450"/>
-          </a:xfrm>
-          <a:prstGeom prst="rect">
-            <a:avLst/>
-          </a:prstGeom>
-        </p:spPr>
-        <p:txBody>
-          <a:bodyPr vert="horz" lIns="91440" tIns="45720" rIns="91440" bIns="45720" rtlCol="0"/>
-          <a:lstStyle/>
-          <a:p>
-            <a:pPr lvl="0"/>
-            <a:r>
-              <a:rPr lang="en-US"/>
-              <a:t>Click to edit Master text styles</a:t>
-            </a:r>
-          </a:p>
-          <a:p>
-            <a:pPr lvl="1"/>
-            <a:r>
-              <a:rPr lang="en-US"/>
-              <a:t>Second level</a:t>
-            </a:r>
-          </a:p>
-          <a:p>
-            <a:pPr lvl="2"/>
-            <a:r>
-              <a:rPr lang="en-US"/>
-              <a:t>Third level</a:t>
-            </a:r>
-          </a:p>
-          <a:p>
-            <a:pPr lvl="3"/>
-            <a:r>
-              <a:rPr lang="en-US"/>
-              <a:t>Fourth level</a:t>
-            </a:r>
-          </a:p>
-          <a:p>
-            <a:pPr lvl="4"/>
-            <a:r>
-              <a:rPr lang="en-US"/>
-              <a:t>Fifth level</a:t>
-            </a:r>
-          </a:p>
-        </p:txBody>
-      </p:sp>
-      <p:sp>
-        <p:nvSpPr>
-          <p:cNvPr id="6" name="Footer Placeholder 5"/>
-          <p:cNvSpPr>
-            <a:spLocks noGrp="1"/>
-          </p:cNvSpPr>
-          <p:nvPr>
-            <p:ph type="ftr" sz="quarter" idx="4"/>
-          </p:nvPr>
-        </p:nvSpPr>
-        <p:spPr>
-          <a:xfrm>
-            <a:off x="0" y="8685213"/>
-            <a:ext cx="2971800" cy="458787"/>
-          </a:xfrm>
-          <a:prstGeom prst="rect">
-            <a:avLst/>
-          </a:prstGeom>
-        </p:spPr>
-        <p:txBody>
-          <a:bodyPr vert="horz" lIns="91440" tIns="45720" rIns="91440" bIns="45720" rtlCol="0" anchor="b"/>
-          <a:lstStyle>
-            <a:lvl1pPr algn="l">
-              <a:defRPr sz="1200"/>
-            </a:lvl1pPr>
-          </a:lstStyle>
-          <a:p>
-            <a:endParaRPr lang="en-US"/>
-          </a:p>
-        </p:txBody>
-      </p:sp>
-      <p:sp>
-        <p:nvSpPr>
-          <p:cNvPr id="7" name="Slide Number Placeholder 6"/>
-          <p:cNvSpPr>
-            <a:spLocks noGrp="1"/>
-          </p:cNvSpPr>
-          <p:nvPr>
-            <p:ph type="sldNum" sz="quarter" idx="5"/>
-          </p:nvPr>
-        </p:nvSpPr>
-        <p:spPr>
-          <a:xfrm>
-            <a:off x="3884613" y="8685213"/>
-            <a:ext cx="2971800" cy="458787"/>
-          </a:xfrm>
-          <a:prstGeom prst="rect">
-            <a:avLst/>
-          </a:prstGeom>
-        </p:spPr>
-        <p:txBody>
-          <a:bodyPr vert="horz" lIns="91440" tIns="45720" rIns="91440" bIns="45720" rtlCol="0" anchor="b"/>
-          <a:lstStyle>
-            <a:lvl1pPr algn="r">
-              <a:defRPr sz="1200"/>
-            </a:lvl1pPr>
-          </a:lstStyle>
-          <a:p>
-            <a:fld id="{CE5E9CC1-C706-0F49-92D6-E571CC5EEA8F}" type="slidenum">
-              <a:rPr lang="en-US"/>
-              <a:t>‹#›</a:t>
-            </a:fld>
-            <a:endParaRPr lang="en-US"/>
-          </a:p>
-        </p:txBody>
-      </p:sp>
     </p:spTree>
     <p:extLst>
       <p:ext uri="{BB962C8B-B14F-4D97-AF65-F5344CB8AC3E}">
-        <p14:creationId xmlns:p14="http://schemas.microsoft.com/office/powerpoint/2010/main" val="1024086991"/>
+        <p14:creationId xmlns:p14="http://schemas.microsoft.com/office/powerpoint/2010/main" val="2550328478"/>
       </p:ext>
     </p:extLst>
   </p:cSld>
@@ -460,7 +241,7 @@
 </file>
 
 <file path=ppt/notesSlides/notesSlide1.xml><?xml version="1.0" encoding="utf-8"?>
-<p:notes xmlns:p14="http://schemas.microsoft.com/office/powerpoint/2010/main" xmlns:a="http://schemas.openxmlformats.org/drawingml/2006/main" xmlns:r="http://schemas.openxmlformats.org/officeDocument/2006/relationships" xmlns:p="http://schemas.openxmlformats.org/presentationml/2006/main">
+<p:notes xmlns:a="http://schemas.openxmlformats.org/drawingml/2006/main" xmlns:r="http://schemas.openxmlformats.org/officeDocument/2006/relationships" xmlns:p="http://schemas.openxmlformats.org/presentationml/2006/main">
   <p:cSld>
     <p:spTree>
       <p:nvGrpSpPr>
@@ -507,7 +288,6 @@
               <a:rPr lang="en-US" dirty="0"/>
               <a:t>SupplyChain AI Copilot — Supply Chain Disruption Assistant &amp; Fleet Utilisation Optimizer. Team Error Fellows, Track AI, IBM Bob AI Hackathon 2026. The system runs a continuous Detect, Assess, Optimise, Act loop.</a:t>
             </a:r>
-            <a:endParaRPr lang="en-US" dirty="0"/>
           </a:p>
         </p:txBody>
       </p:sp>
@@ -548,7 +328,7 @@
 </file>
 
 <file path=ppt/notesSlides/notesSlide2.xml><?xml version="1.0" encoding="utf-8"?>
-<p:notes xmlns:p14="http://schemas.microsoft.com/office/powerpoint/2010/main" xmlns:a="http://schemas.openxmlformats.org/drawingml/2006/main" xmlns:r="http://schemas.openxmlformats.org/officeDocument/2006/relationships" xmlns:p="http://schemas.openxmlformats.org/presentationml/2006/main">
+<p:notes xmlns:a="http://schemas.openxmlformats.org/drawingml/2006/main" xmlns:r="http://schemas.openxmlformats.org/officeDocument/2006/relationships" xmlns:p="http://schemas.openxmlformats.org/presentationml/2006/main">
   <p:cSld>
     <p:spTree>
       <p:nvGrpSpPr>
@@ -595,7 +375,6 @@
               <a:rPr lang="en-US" dirty="0"/>
               <a:t>Pharmaceutical cold-chain teams face two simultaneous crises. First, disruption blindness: manual triage of a port strike or storm takes 2–4 hours. Second, cold-chain excursions are discovered only at delivery. Pain numbers: $500K+ per rejected vaccine shipment, $10B+ per major port event, 4–8 hours per manual GDP excursion report.</a:t>
             </a:r>
-            <a:endParaRPr lang="en-US" dirty="0"/>
           </a:p>
         </p:txBody>
       </p:sp>
@@ -636,7 +415,7 @@
 </file>
 
 <file path=ppt/notesSlides/notesSlide3.xml><?xml version="1.0" encoding="utf-8"?>
-<p:notes xmlns:p14="http://schemas.microsoft.com/office/powerpoint/2010/main" xmlns:a="http://schemas.openxmlformats.org/drawingml/2006/main" xmlns:r="http://schemas.openxmlformats.org/officeDocument/2006/relationships" xmlns:p="http://schemas.openxmlformats.org/presentationml/2006/main">
+<p:notes xmlns:a="http://schemas.openxmlformats.org/drawingml/2006/main" xmlns:r="http://schemas.openxmlformats.org/officeDocument/2006/relationships" xmlns:p="http://schemas.openxmlformats.org/presentationml/2006/main">
   <p:cSld>
     <p:spTree>
       <p:nvGrpSpPr>
@@ -683,7 +462,6 @@
               <a:rPr lang="en-US" dirty="0"/>
               <a:t>One system that detects exposed shipments geospatially, scores them with a 6-factor deterministic engine, optimises reroutes and idle reefer fleet matching, acts through a human-approved workflow with immutable audit trail, and monitors cold-chain IoT telemetry 24/7 with watsonx.ai excursion classification before delivery.</a:t>
             </a:r>
-            <a:endParaRPr lang="en-US" dirty="0"/>
           </a:p>
         </p:txBody>
       </p:sp>
@@ -724,7 +502,7 @@
 </file>
 
 <file path=ppt/notesSlides/notesSlide4.xml><?xml version="1.0" encoding="utf-8"?>
-<p:notes xmlns:p14="http://schemas.microsoft.com/office/powerpoint/2010/main" xmlns:a="http://schemas.openxmlformats.org/drawingml/2006/main" xmlns:r="http://schemas.openxmlformats.org/officeDocument/2006/relationships" xmlns:p="http://schemas.openxmlformats.org/presentationml/2006/main">
+<p:notes xmlns:a="http://schemas.openxmlformats.org/drawingml/2006/main" xmlns:r="http://schemas.openxmlformats.org/officeDocument/2006/relationships" xmlns:p="http://schemas.openxmlformats.org/presentationml/2006/main">
   <p:cSld>
     <p:spTree>
       <p:nvGrpSpPr>
@@ -771,7 +549,6 @@
               <a:rPr lang="en-US" dirty="0"/>
               <a:t>Three input streams. IoT sensor readings every 5 seconds go to the Cold Chain Engine, then watsonx.ai for GDP classification. Disruption events flow through Impact, Risk, Route Optimizer and Fleet Matcher into the AI Action Center. Operator chat goes to the watsonx.ai Copilot with live system context. Key principle: AI explains, deterministic engines calculate the facts.</a:t>
             </a:r>
-            <a:endParaRPr lang="en-US" dirty="0"/>
           </a:p>
         </p:txBody>
       </p:sp>
@@ -844,6 +621,11 @@
 <file path=ppt/slideMasters/slideMaster1.xml><?xml version="1.0" encoding="utf-8"?>
 <p:sldMaster xmlns:a="http://schemas.openxmlformats.org/drawingml/2006/main" xmlns:r="http://schemas.openxmlformats.org/officeDocument/2006/relationships" xmlns:p="http://schemas.openxmlformats.org/presentationml/2006/main">
   <p:cSld>
+    <p:bg>
+      <p:bgRef idx="1001">
+        <a:schemeClr val="bg1"/>
+      </p:bgRef>
+    </p:bg>
     <p:spTree>
       <p:nvGrpSpPr>
         <p:cNvPr id="1" name=""/>
@@ -1126,6 +908,7 @@
         <a:solidFill>
           <a:srgbClr val="0B1426"/>
         </a:solidFill>
+        <a:effectLst/>
       </p:bgPr>
     </p:bg>
     <p:spTree>
@@ -1285,6 +1068,13 @@
             <a:prstDash val="solid"/>
           </a:ln>
         </p:spPr>
+        <p:txBody>
+          <a:bodyPr/>
+          <a:lstStyle/>
+          <a:p>
+            <a:endParaRPr lang="en-IN"/>
+          </a:p>
+        </p:txBody>
       </p:sp>
       <p:sp>
         <p:nvSpPr>
@@ -1351,6 +1141,13 @@
             <a:prstDash val="solid"/>
           </a:ln>
         </p:spPr>
+        <p:txBody>
+          <a:bodyPr/>
+          <a:lstStyle/>
+          <a:p>
+            <a:endParaRPr lang="en-IN"/>
+          </a:p>
+        </p:txBody>
       </p:sp>
       <p:sp>
         <p:nvSpPr>
@@ -1417,6 +1214,13 @@
             <a:prstDash val="solid"/>
           </a:ln>
         </p:spPr>
+        <p:txBody>
+          <a:bodyPr/>
+          <a:lstStyle/>
+          <a:p>
+            <a:endParaRPr lang="en-IN"/>
+          </a:p>
+        </p:txBody>
       </p:sp>
       <p:sp>
         <p:nvSpPr>
@@ -1442,240 +1246,17 @@
             <a:prstDash val="solid"/>
           </a:ln>
         </p:spPr>
+        <p:txBody>
+          <a:bodyPr/>
+          <a:lstStyle/>
+          <a:p>
+            <a:endParaRPr lang="en-IN"/>
+          </a:p>
+        </p:txBody>
       </p:sp>
       <p:pic>
         <p:nvPicPr>
           <p:cNvPr id="11" name="Image 0" descr="preencoded.png"/>
-          <p:cNvPicPr>
-            <a:picLocks noChangeAspect="1"/>
-          </p:cNvPicPr>
-          <p:nvPr/>
-        </p:nvPicPr>
-        <p:blipFill>
-          <a:blip r:embed="rId1"/>
-          <a:stretch>
-            <a:fillRect/>
-          </a:stretch>
-        </p:blipFill>
-        <p:spPr>
-          <a:xfrm>
-            <a:off x="6291072" y="1463040"/>
-            <a:ext cx="274320" cy="274320"/>
-          </a:xfrm>
-          <a:prstGeom prst="rect">
-            <a:avLst/>
-          </a:prstGeom>
-        </p:spPr>
-      </p:pic>
-      <p:sp>
-        <p:nvSpPr>
-          <p:cNvPr id="12" name="Text 9"/>
-          <p:cNvSpPr txBox="1"/>
-          <p:nvPr/>
-        </p:nvSpPr>
-        <p:spPr>
-          <a:xfrm>
-            <a:off x="5760720" y="1993392"/>
-            <a:ext cx="1325880" cy="274320"/>
-          </a:xfrm>
-          <a:prstGeom prst="rect">
-            <a:avLst/>
-          </a:prstGeom>
-          <a:noFill/>
-          <a:ln/>
-        </p:spPr>
-        <p:txBody>
-          <a:bodyPr wrap="square" lIns="0" tIns="0" rIns="0" bIns="0" rtlCol="0" anchor="t"/>
-          <a:lstStyle/>
-          <a:p>
-            <a:pPr marL="0" indent="0" algn="ctr">
-              <a:buNone/>
-            </a:pPr>
-            <a:r>
-              <a:rPr lang="en-US" sz="1400" b="1" dirty="0">
-                <a:solidFill>
-                  <a:srgbClr val="F1F5F9"/>
-                </a:solidFill>
-                <a:latin typeface="Calibri" pitchFamily="34" charset="0"/>
-                <a:ea typeface="Calibri" pitchFamily="34" charset="-122"/>
-                <a:cs typeface="Calibri" pitchFamily="34" charset="-120"/>
-              </a:rPr>
-              <a:t>Detect</a:t>
-            </a:r>
-            <a:endParaRPr lang="en-US" sz="1400" dirty="0"/>
-          </a:p>
-        </p:txBody>
-      </p:sp>
-      <p:sp>
-        <p:nvSpPr>
-          <p:cNvPr id="13" name="Shape 10"/>
-          <p:cNvSpPr/>
-          <p:nvPr/>
-        </p:nvSpPr>
-        <p:spPr>
-          <a:xfrm>
-            <a:off x="7269480" y="1097280"/>
-            <a:ext cx="1325880" cy="1325880"/>
-          </a:xfrm>
-          <a:prstGeom prst="roundRect">
-            <a:avLst>
-              <a:gd name="adj" fmla="val 5517"/>
-            </a:avLst>
-          </a:prstGeom>
-          <a:solidFill>
-            <a:srgbClr val="14213D"/>
-          </a:solidFill>
-          <a:ln w="12700">
-            <a:solidFill>
-              <a:srgbClr val="14213D"/>
-            </a:solidFill>
-            <a:prstDash val="solid"/>
-          </a:ln>
-        </p:spPr>
-      </p:sp>
-      <p:sp>
-        <p:nvSpPr>
-          <p:cNvPr id="14" name="Shape 11"/>
-          <p:cNvSpPr/>
-          <p:nvPr/>
-        </p:nvSpPr>
-        <p:spPr>
-          <a:xfrm>
-            <a:off x="7662672" y="1325880"/>
-            <a:ext cx="548640" cy="548640"/>
-          </a:xfrm>
-          <a:prstGeom prst="ellipse">
-            <a:avLst/>
-          </a:prstGeom>
-          <a:solidFill>
-            <a:srgbClr val="0E3A4A"/>
-          </a:solidFill>
-          <a:ln w="12700">
-            <a:solidFill>
-              <a:srgbClr val="0E3A4A"/>
-            </a:solidFill>
-            <a:prstDash val="solid"/>
-          </a:ln>
-        </p:spPr>
-      </p:sp>
-      <p:pic>
-        <p:nvPicPr>
-          <p:cNvPr id="15" name="Image 1" descr="preencoded.png"/>
-          <p:cNvPicPr>
-            <a:picLocks noChangeAspect="1"/>
-          </p:cNvPicPr>
-          <p:nvPr/>
-        </p:nvPicPr>
-        <p:blipFill>
-          <a:blip r:embed="rId2"/>
-          <a:stretch>
-            <a:fillRect/>
-          </a:stretch>
-        </p:blipFill>
-        <p:spPr>
-          <a:xfrm>
-            <a:off x="7799832" y="1463040"/>
-            <a:ext cx="274320" cy="274320"/>
-          </a:xfrm>
-          <a:prstGeom prst="rect">
-            <a:avLst/>
-          </a:prstGeom>
-        </p:spPr>
-      </p:pic>
-      <p:sp>
-        <p:nvSpPr>
-          <p:cNvPr id="16" name="Text 12"/>
-          <p:cNvSpPr txBox="1"/>
-          <p:nvPr/>
-        </p:nvSpPr>
-        <p:spPr>
-          <a:xfrm>
-            <a:off x="7269480" y="1993392"/>
-            <a:ext cx="1325880" cy="274320"/>
-          </a:xfrm>
-          <a:prstGeom prst="rect">
-            <a:avLst/>
-          </a:prstGeom>
-          <a:noFill/>
-          <a:ln/>
-        </p:spPr>
-        <p:txBody>
-          <a:bodyPr wrap="square" lIns="0" tIns="0" rIns="0" bIns="0" rtlCol="0" anchor="t"/>
-          <a:lstStyle/>
-          <a:p>
-            <a:pPr marL="0" indent="0" algn="ctr">
-              <a:buNone/>
-            </a:pPr>
-            <a:r>
-              <a:rPr lang="en-US" sz="1400" b="1" dirty="0">
-                <a:solidFill>
-                  <a:srgbClr val="F1F5F9"/>
-                </a:solidFill>
-                <a:latin typeface="Calibri" pitchFamily="34" charset="0"/>
-                <a:ea typeface="Calibri" pitchFamily="34" charset="-122"/>
-                <a:cs typeface="Calibri" pitchFamily="34" charset="-120"/>
-              </a:rPr>
-              <a:t>Assess</a:t>
-            </a:r>
-            <a:endParaRPr lang="en-US" sz="1400" dirty="0"/>
-          </a:p>
-        </p:txBody>
-      </p:sp>
-      <p:sp>
-        <p:nvSpPr>
-          <p:cNvPr id="17" name="Shape 13"/>
-          <p:cNvSpPr/>
-          <p:nvPr/>
-        </p:nvSpPr>
-        <p:spPr>
-          <a:xfrm>
-            <a:off x="5760720" y="2606040"/>
-            <a:ext cx="1325880" cy="1325880"/>
-          </a:xfrm>
-          <a:prstGeom prst="roundRect">
-            <a:avLst>
-              <a:gd name="adj" fmla="val 5517"/>
-            </a:avLst>
-          </a:prstGeom>
-          <a:solidFill>
-            <a:srgbClr val="14213D"/>
-          </a:solidFill>
-          <a:ln w="12700">
-            <a:solidFill>
-              <a:srgbClr val="14213D"/>
-            </a:solidFill>
-            <a:prstDash val="solid"/>
-          </a:ln>
-        </p:spPr>
-      </p:sp>
-      <p:sp>
-        <p:nvSpPr>
-          <p:cNvPr id="18" name="Shape 14"/>
-          <p:cNvSpPr/>
-          <p:nvPr/>
-        </p:nvSpPr>
-        <p:spPr>
-          <a:xfrm>
-            <a:off x="6153912" y="2834640"/>
-            <a:ext cx="548640" cy="548640"/>
-          </a:xfrm>
-          <a:prstGeom prst="ellipse">
-            <a:avLst/>
-          </a:prstGeom>
-          <a:solidFill>
-            <a:srgbClr val="0E3A4A"/>
-          </a:solidFill>
-          <a:ln w="12700">
-            <a:solidFill>
-              <a:srgbClr val="0E3A4A"/>
-            </a:solidFill>
-            <a:prstDash val="solid"/>
-          </a:ln>
-        </p:spPr>
-      </p:sp>
-      <p:pic>
-        <p:nvPicPr>
-          <p:cNvPr id="19" name="Image 2" descr="preencoded.png"/>
           <p:cNvPicPr>
             <a:picLocks noChangeAspect="1"/>
           </p:cNvPicPr>
@@ -1689,7 +1270,7 @@
         </p:blipFill>
         <p:spPr>
           <a:xfrm>
-            <a:off x="6291072" y="2971800"/>
+            <a:off x="6291072" y="1463040"/>
             <a:ext cx="274320" cy="274320"/>
           </a:xfrm>
           <a:prstGeom prst="rect">
@@ -1699,13 +1280,13 @@
       </p:pic>
       <p:sp>
         <p:nvSpPr>
-          <p:cNvPr id="20" name="Text 15"/>
+          <p:cNvPr id="12" name="Text 9"/>
           <p:cNvSpPr txBox="1"/>
           <p:nvPr/>
         </p:nvSpPr>
         <p:spPr>
           <a:xfrm>
-            <a:off x="5760720" y="3502152"/>
+            <a:off x="5760720" y="1993392"/>
             <a:ext cx="1325880" cy="274320"/>
           </a:xfrm>
           <a:prstGeom prst="rect">
@@ -1730,7 +1311,7 @@
                 <a:ea typeface="Calibri" pitchFamily="34" charset="-122"/>
                 <a:cs typeface="Calibri" pitchFamily="34" charset="-120"/>
               </a:rPr>
-              <a:t>Optimise</a:t>
+              <a:t>Detect</a:t>
             </a:r>
             <a:endParaRPr lang="en-US" sz="1400" dirty="0"/>
           </a:p>
@@ -1738,13 +1319,13 @@
       </p:sp>
       <p:sp>
         <p:nvSpPr>
-          <p:cNvPr id="21" name="Shape 16"/>
+          <p:cNvPr id="13" name="Shape 10"/>
           <p:cNvSpPr/>
           <p:nvPr/>
         </p:nvSpPr>
         <p:spPr>
           <a:xfrm>
-            <a:off x="7269480" y="2606040"/>
+            <a:off x="7269480" y="1097280"/>
             <a:ext cx="1325880" cy="1325880"/>
           </a:xfrm>
           <a:prstGeom prst="roundRect">
@@ -1762,16 +1343,23 @@
             <a:prstDash val="solid"/>
           </a:ln>
         </p:spPr>
-      </p:sp>
-      <p:sp>
-        <p:nvSpPr>
-          <p:cNvPr id="22" name="Shape 17"/>
+        <p:txBody>
+          <a:bodyPr/>
+          <a:lstStyle/>
+          <a:p>
+            <a:endParaRPr lang="en-IN"/>
+          </a:p>
+        </p:txBody>
+      </p:sp>
+      <p:sp>
+        <p:nvSpPr>
+          <p:cNvPr id="14" name="Shape 11"/>
           <p:cNvSpPr/>
           <p:nvPr/>
         </p:nvSpPr>
         <p:spPr>
           <a:xfrm>
-            <a:off x="7662672" y="2834640"/>
+            <a:off x="7662672" y="1325880"/>
             <a:ext cx="548640" cy="548640"/>
           </a:xfrm>
           <a:prstGeom prst="ellipse">
@@ -1787,6 +1375,271 @@
             <a:prstDash val="solid"/>
           </a:ln>
         </p:spPr>
+        <p:txBody>
+          <a:bodyPr/>
+          <a:lstStyle/>
+          <a:p>
+            <a:endParaRPr lang="en-IN"/>
+          </a:p>
+        </p:txBody>
+      </p:sp>
+      <p:pic>
+        <p:nvPicPr>
+          <p:cNvPr id="15" name="Image 1" descr="preencoded.png"/>
+          <p:cNvPicPr>
+            <a:picLocks noChangeAspect="1"/>
+          </p:cNvPicPr>
+          <p:nvPr/>
+        </p:nvPicPr>
+        <p:blipFill>
+          <a:blip r:embed="rId4"/>
+          <a:stretch>
+            <a:fillRect/>
+          </a:stretch>
+        </p:blipFill>
+        <p:spPr>
+          <a:xfrm>
+            <a:off x="7799832" y="1463040"/>
+            <a:ext cx="274320" cy="274320"/>
+          </a:xfrm>
+          <a:prstGeom prst="rect">
+            <a:avLst/>
+          </a:prstGeom>
+        </p:spPr>
+      </p:pic>
+      <p:sp>
+        <p:nvSpPr>
+          <p:cNvPr id="16" name="Text 12"/>
+          <p:cNvSpPr txBox="1"/>
+          <p:nvPr/>
+        </p:nvSpPr>
+        <p:spPr>
+          <a:xfrm>
+            <a:off x="7269480" y="1993392"/>
+            <a:ext cx="1325880" cy="274320"/>
+          </a:xfrm>
+          <a:prstGeom prst="rect">
+            <a:avLst/>
+          </a:prstGeom>
+          <a:noFill/>
+          <a:ln/>
+        </p:spPr>
+        <p:txBody>
+          <a:bodyPr wrap="square" lIns="0" tIns="0" rIns="0" bIns="0" rtlCol="0" anchor="t"/>
+          <a:lstStyle/>
+          <a:p>
+            <a:pPr marL="0" indent="0" algn="ctr">
+              <a:buNone/>
+            </a:pPr>
+            <a:r>
+              <a:rPr lang="en-US" sz="1400" b="1" dirty="0">
+                <a:solidFill>
+                  <a:srgbClr val="F1F5F9"/>
+                </a:solidFill>
+                <a:latin typeface="Calibri" pitchFamily="34" charset="0"/>
+                <a:ea typeface="Calibri" pitchFamily="34" charset="-122"/>
+                <a:cs typeface="Calibri" pitchFamily="34" charset="-120"/>
+              </a:rPr>
+              <a:t>Assess</a:t>
+            </a:r>
+            <a:endParaRPr lang="en-US" sz="1400" dirty="0"/>
+          </a:p>
+        </p:txBody>
+      </p:sp>
+      <p:sp>
+        <p:nvSpPr>
+          <p:cNvPr id="17" name="Shape 13"/>
+          <p:cNvSpPr/>
+          <p:nvPr/>
+        </p:nvSpPr>
+        <p:spPr>
+          <a:xfrm>
+            <a:off x="5760720" y="2606040"/>
+            <a:ext cx="1325880" cy="1325880"/>
+          </a:xfrm>
+          <a:prstGeom prst="roundRect">
+            <a:avLst>
+              <a:gd name="adj" fmla="val 5517"/>
+            </a:avLst>
+          </a:prstGeom>
+          <a:solidFill>
+            <a:srgbClr val="14213D"/>
+          </a:solidFill>
+          <a:ln w="12700">
+            <a:solidFill>
+              <a:srgbClr val="14213D"/>
+            </a:solidFill>
+            <a:prstDash val="solid"/>
+          </a:ln>
+        </p:spPr>
+        <p:txBody>
+          <a:bodyPr/>
+          <a:lstStyle/>
+          <a:p>
+            <a:endParaRPr lang="en-IN"/>
+          </a:p>
+        </p:txBody>
+      </p:sp>
+      <p:sp>
+        <p:nvSpPr>
+          <p:cNvPr id="18" name="Shape 14"/>
+          <p:cNvSpPr/>
+          <p:nvPr/>
+        </p:nvSpPr>
+        <p:spPr>
+          <a:xfrm>
+            <a:off x="6153912" y="2834640"/>
+            <a:ext cx="548640" cy="548640"/>
+          </a:xfrm>
+          <a:prstGeom prst="ellipse">
+            <a:avLst/>
+          </a:prstGeom>
+          <a:solidFill>
+            <a:srgbClr val="0E3A4A"/>
+          </a:solidFill>
+          <a:ln w="12700">
+            <a:solidFill>
+              <a:srgbClr val="0E3A4A"/>
+            </a:solidFill>
+            <a:prstDash val="solid"/>
+          </a:ln>
+        </p:spPr>
+        <p:txBody>
+          <a:bodyPr/>
+          <a:lstStyle/>
+          <a:p>
+            <a:endParaRPr lang="en-IN"/>
+          </a:p>
+        </p:txBody>
+      </p:sp>
+      <p:pic>
+        <p:nvPicPr>
+          <p:cNvPr id="19" name="Image 2" descr="preencoded.png"/>
+          <p:cNvPicPr>
+            <a:picLocks noChangeAspect="1"/>
+          </p:cNvPicPr>
+          <p:nvPr/>
+        </p:nvPicPr>
+        <p:blipFill>
+          <a:blip r:embed="rId5"/>
+          <a:stretch>
+            <a:fillRect/>
+          </a:stretch>
+        </p:blipFill>
+        <p:spPr>
+          <a:xfrm>
+            <a:off x="6291072" y="2971800"/>
+            <a:ext cx="274320" cy="274320"/>
+          </a:xfrm>
+          <a:prstGeom prst="rect">
+            <a:avLst/>
+          </a:prstGeom>
+        </p:spPr>
+      </p:pic>
+      <p:sp>
+        <p:nvSpPr>
+          <p:cNvPr id="20" name="Text 15"/>
+          <p:cNvSpPr txBox="1"/>
+          <p:nvPr/>
+        </p:nvSpPr>
+        <p:spPr>
+          <a:xfrm>
+            <a:off x="5760720" y="3502152"/>
+            <a:ext cx="1325880" cy="274320"/>
+          </a:xfrm>
+          <a:prstGeom prst="rect">
+            <a:avLst/>
+          </a:prstGeom>
+          <a:noFill/>
+          <a:ln/>
+        </p:spPr>
+        <p:txBody>
+          <a:bodyPr wrap="square" lIns="0" tIns="0" rIns="0" bIns="0" rtlCol="0" anchor="t"/>
+          <a:lstStyle/>
+          <a:p>
+            <a:pPr marL="0" indent="0" algn="ctr">
+              <a:buNone/>
+            </a:pPr>
+            <a:r>
+              <a:rPr lang="en-US" sz="1400" b="1" dirty="0">
+                <a:solidFill>
+                  <a:srgbClr val="F1F5F9"/>
+                </a:solidFill>
+                <a:latin typeface="Calibri" pitchFamily="34" charset="0"/>
+                <a:ea typeface="Calibri" pitchFamily="34" charset="-122"/>
+                <a:cs typeface="Calibri" pitchFamily="34" charset="-120"/>
+              </a:rPr>
+              <a:t>Optimise</a:t>
+            </a:r>
+            <a:endParaRPr lang="en-US" sz="1400" dirty="0"/>
+          </a:p>
+        </p:txBody>
+      </p:sp>
+      <p:sp>
+        <p:nvSpPr>
+          <p:cNvPr id="21" name="Shape 16"/>
+          <p:cNvSpPr/>
+          <p:nvPr/>
+        </p:nvSpPr>
+        <p:spPr>
+          <a:xfrm>
+            <a:off x="7269480" y="2606040"/>
+            <a:ext cx="1325880" cy="1325880"/>
+          </a:xfrm>
+          <a:prstGeom prst="roundRect">
+            <a:avLst>
+              <a:gd name="adj" fmla="val 5517"/>
+            </a:avLst>
+          </a:prstGeom>
+          <a:solidFill>
+            <a:srgbClr val="14213D"/>
+          </a:solidFill>
+          <a:ln w="12700">
+            <a:solidFill>
+              <a:srgbClr val="14213D"/>
+            </a:solidFill>
+            <a:prstDash val="solid"/>
+          </a:ln>
+        </p:spPr>
+        <p:txBody>
+          <a:bodyPr/>
+          <a:lstStyle/>
+          <a:p>
+            <a:endParaRPr lang="en-IN"/>
+          </a:p>
+        </p:txBody>
+      </p:sp>
+      <p:sp>
+        <p:nvSpPr>
+          <p:cNvPr id="22" name="Shape 17"/>
+          <p:cNvSpPr/>
+          <p:nvPr/>
+        </p:nvSpPr>
+        <p:spPr>
+          <a:xfrm>
+            <a:off x="7662672" y="2834640"/>
+            <a:ext cx="548640" cy="548640"/>
+          </a:xfrm>
+          <a:prstGeom prst="ellipse">
+            <a:avLst/>
+          </a:prstGeom>
+          <a:solidFill>
+            <a:srgbClr val="0E3A4A"/>
+          </a:solidFill>
+          <a:ln w="12700">
+            <a:solidFill>
+              <a:srgbClr val="0E3A4A"/>
+            </a:solidFill>
+            <a:prstDash val="solid"/>
+          </a:ln>
+        </p:spPr>
+        <p:txBody>
+          <a:bodyPr/>
+          <a:lstStyle/>
+          <a:p>
+            <a:endParaRPr lang="en-IN"/>
+          </a:p>
+        </p:txBody>
       </p:sp>
       <p:pic>
         <p:nvPicPr>
@@ -1797,7 +1650,7 @@
           <p:nvPr/>
         </p:nvPicPr>
         <p:blipFill>
-          <a:blip r:embed="rId4"/>
+          <a:blip r:embed="rId6"/>
           <a:stretch>
             <a:fillRect/>
           </a:stretch>
@@ -1867,6 +1720,7 @@
         <a:solidFill>
           <a:srgbClr val="0B1426"/>
         </a:solidFill>
+        <a:effectLst/>
       </p:bgPr>
     </p:bg>
     <p:spTree>
@@ -2026,6 +1880,13 @@
             <a:prstDash val="solid"/>
           </a:ln>
         </p:spPr>
+        <p:txBody>
+          <a:bodyPr/>
+          <a:lstStyle/>
+          <a:p>
+            <a:endParaRPr lang="en-IN"/>
+          </a:p>
+        </p:txBody>
       </p:sp>
       <p:sp>
         <p:nvSpPr>
@@ -2051,6 +1912,13 @@
             <a:prstDash val="solid"/>
           </a:ln>
         </p:spPr>
+        <p:txBody>
+          <a:bodyPr/>
+          <a:lstStyle/>
+          <a:p>
+            <a:endParaRPr lang="en-IN"/>
+          </a:p>
+        </p:txBody>
       </p:sp>
       <p:pic>
         <p:nvPicPr>
@@ -2061,7 +1929,7 @@
           <p:nvPr/>
         </p:nvPicPr>
         <p:blipFill>
-          <a:blip r:embed="rId1"/>
+          <a:blip r:embed="rId3"/>
           <a:stretch>
             <a:fillRect/>
           </a:stretch>
@@ -2180,6 +2048,13 @@
             <a:prstDash val="solid"/>
           </a:ln>
         </p:spPr>
+        <p:txBody>
+          <a:bodyPr/>
+          <a:lstStyle/>
+          <a:p>
+            <a:endParaRPr lang="en-IN"/>
+          </a:p>
+        </p:txBody>
       </p:sp>
       <p:sp>
         <p:nvSpPr>
@@ -2205,6 +2080,13 @@
             <a:prstDash val="solid"/>
           </a:ln>
         </p:spPr>
+        <p:txBody>
+          <a:bodyPr/>
+          <a:lstStyle/>
+          <a:p>
+            <a:endParaRPr lang="en-IN"/>
+          </a:p>
+        </p:txBody>
       </p:sp>
       <p:pic>
         <p:nvPicPr>
@@ -2215,7 +2097,7 @@
           <p:nvPr/>
         </p:nvPicPr>
         <p:blipFill>
-          <a:blip r:embed="rId2"/>
+          <a:blip r:embed="rId4"/>
           <a:stretch>
             <a:fillRect/>
           </a:stretch>
@@ -2558,6 +2440,7 @@
         <a:solidFill>
           <a:srgbClr val="0B1426"/>
         </a:solidFill>
+        <a:effectLst/>
       </p:bgPr>
     </p:bg>
     <p:spTree>
@@ -2638,7 +2521,7 @@
               <a:buNone/>
             </a:pPr>
             <a:r>
-              <a:rPr lang="en-US" sz="2800" b="1" dirty="0">
+              <a:rPr lang="en-US" sz="2200" b="1" dirty="0">
                 <a:solidFill>
                   <a:srgbClr val="F1F5F9"/>
                 </a:solidFill>
@@ -2648,7 +2531,7 @@
               </a:rPr>
               <a:t>Every shipment has two deadlines. We compute both.</a:t>
             </a:r>
-            <a:endParaRPr lang="en-US" sz="2800" dirty="0"/>
+            <a:endParaRPr lang="en-US" sz="2200" dirty="0"/>
           </a:p>
         </p:txBody>
       </p:sp>
@@ -2756,6 +2639,13 @@
             <a:prstDash val="solid"/>
           </a:ln>
         </p:spPr>
+        <p:txBody>
+          <a:bodyPr/>
+          <a:lstStyle/>
+          <a:p>
+            <a:endParaRPr lang="en-IN"/>
+          </a:p>
+        </p:txBody>
       </p:sp>
       <p:sp>
         <p:nvSpPr>
@@ -2781,6 +2671,13 @@
             <a:prstDash val="solid"/>
           </a:ln>
         </p:spPr>
+        <p:txBody>
+          <a:bodyPr/>
+          <a:lstStyle/>
+          <a:p>
+            <a:endParaRPr lang="en-IN"/>
+          </a:p>
+        </p:txBody>
       </p:sp>
       <p:pic>
         <p:nvPicPr>
@@ -2791,7 +2688,7 @@
           <p:nvPr/>
         </p:nvPicPr>
         <p:blipFill>
-          <a:blip r:embed="rId1"/>
+          <a:blip r:embed="rId3"/>
           <a:stretch>
             <a:fillRect/>
           </a:stretch>
@@ -2907,6 +2804,13 @@
             <a:tailEnd type="triangle"/>
           </a:ln>
         </p:spPr>
+        <p:txBody>
+          <a:bodyPr/>
+          <a:lstStyle/>
+          <a:p>
+            <a:endParaRPr lang="en-IN"/>
+          </a:p>
+        </p:txBody>
       </p:sp>
       <p:sp>
         <p:nvSpPr>
@@ -2934,6 +2838,13 @@
             <a:prstDash val="solid"/>
           </a:ln>
         </p:spPr>
+        <p:txBody>
+          <a:bodyPr/>
+          <a:lstStyle/>
+          <a:p>
+            <a:endParaRPr lang="en-IN"/>
+          </a:p>
+        </p:txBody>
       </p:sp>
       <p:sp>
         <p:nvSpPr>
@@ -2959,6 +2870,13 @@
             <a:prstDash val="solid"/>
           </a:ln>
         </p:spPr>
+        <p:txBody>
+          <a:bodyPr/>
+          <a:lstStyle/>
+          <a:p>
+            <a:endParaRPr lang="en-IN"/>
+          </a:p>
+        </p:txBody>
       </p:sp>
       <p:pic>
         <p:nvPicPr>
@@ -2969,7 +2887,7 @@
           <p:nvPr/>
         </p:nvPicPr>
         <p:blipFill>
-          <a:blip r:embed="rId2"/>
+          <a:blip r:embed="rId4"/>
           <a:stretch>
             <a:fillRect/>
           </a:stretch>
@@ -3085,6 +3003,13 @@
             <a:tailEnd type="triangle"/>
           </a:ln>
         </p:spPr>
+        <p:txBody>
+          <a:bodyPr/>
+          <a:lstStyle/>
+          <a:p>
+            <a:endParaRPr lang="en-IN"/>
+          </a:p>
+        </p:txBody>
       </p:sp>
       <p:sp>
         <p:nvSpPr>
@@ -3112,6 +3037,13 @@
             <a:prstDash val="solid"/>
           </a:ln>
         </p:spPr>
+        <p:txBody>
+          <a:bodyPr/>
+          <a:lstStyle/>
+          <a:p>
+            <a:endParaRPr lang="en-IN"/>
+          </a:p>
+        </p:txBody>
       </p:sp>
       <p:sp>
         <p:nvSpPr>
@@ -3137,6 +3069,13 @@
             <a:prstDash val="solid"/>
           </a:ln>
         </p:spPr>
+        <p:txBody>
+          <a:bodyPr/>
+          <a:lstStyle/>
+          <a:p>
+            <a:endParaRPr lang="en-IN"/>
+          </a:p>
+        </p:txBody>
       </p:sp>
       <p:pic>
         <p:nvPicPr>
@@ -3147,7 +3086,7 @@
           <p:nvPr/>
         </p:nvPicPr>
         <p:blipFill>
-          <a:blip r:embed="rId3"/>
+          <a:blip r:embed="rId5"/>
           <a:stretch>
             <a:fillRect/>
           </a:stretch>
@@ -3263,6 +3202,13 @@
             <a:tailEnd type="triangle"/>
           </a:ln>
         </p:spPr>
+        <p:txBody>
+          <a:bodyPr/>
+          <a:lstStyle/>
+          <a:p>
+            <a:endParaRPr lang="en-IN"/>
+          </a:p>
+        </p:txBody>
       </p:sp>
       <p:sp>
         <p:nvSpPr>
@@ -3290,6 +3236,13 @@
             <a:prstDash val="solid"/>
           </a:ln>
         </p:spPr>
+        <p:txBody>
+          <a:bodyPr/>
+          <a:lstStyle/>
+          <a:p>
+            <a:endParaRPr lang="en-IN"/>
+          </a:p>
+        </p:txBody>
       </p:sp>
       <p:sp>
         <p:nvSpPr>
@@ -3315,6 +3268,13 @@
             <a:prstDash val="solid"/>
           </a:ln>
         </p:spPr>
+        <p:txBody>
+          <a:bodyPr/>
+          <a:lstStyle/>
+          <a:p>
+            <a:endParaRPr lang="en-IN"/>
+          </a:p>
+        </p:txBody>
       </p:sp>
       <p:pic>
         <p:nvPicPr>
@@ -3325,7 +3285,7 @@
           <p:nvPr/>
         </p:nvPicPr>
         <p:blipFill>
-          <a:blip r:embed="rId4"/>
+          <a:blip r:embed="rId6"/>
           <a:stretch>
             <a:fillRect/>
           </a:stretch>
@@ -3441,6 +3401,13 @@
             <a:tailEnd type="triangle"/>
           </a:ln>
         </p:spPr>
+        <p:txBody>
+          <a:bodyPr/>
+          <a:lstStyle/>
+          <a:p>
+            <a:endParaRPr lang="en-IN"/>
+          </a:p>
+        </p:txBody>
       </p:sp>
       <p:sp>
         <p:nvSpPr>
@@ -3468,6 +3435,13 @@
             <a:prstDash val="solid"/>
           </a:ln>
         </p:spPr>
+        <p:txBody>
+          <a:bodyPr/>
+          <a:lstStyle/>
+          <a:p>
+            <a:endParaRPr lang="en-IN"/>
+          </a:p>
+        </p:txBody>
       </p:sp>
       <p:sp>
         <p:nvSpPr>
@@ -3493,6 +3467,13 @@
             <a:prstDash val="solid"/>
           </a:ln>
         </p:spPr>
+        <p:txBody>
+          <a:bodyPr/>
+          <a:lstStyle/>
+          <a:p>
+            <a:endParaRPr lang="en-IN"/>
+          </a:p>
+        </p:txBody>
       </p:sp>
       <p:pic>
         <p:nvPicPr>
@@ -3503,7 +3484,7 @@
           <p:nvPr/>
         </p:nvPicPr>
         <p:blipFill>
-          <a:blip r:embed="rId5"/>
+          <a:blip r:embed="rId7"/>
           <a:stretch>
             <a:fillRect/>
           </a:stretch>
@@ -3651,6 +3632,7 @@
         <a:solidFill>
           <a:srgbClr val="0B1426"/>
         </a:solidFill>
+        <a:effectLst/>
       </p:bgPr>
     </p:bg>
     <p:spTree>
@@ -3731,7 +3713,7 @@
               <a:buNone/>
             </a:pPr>
             <a:r>
-              <a:rPr lang="en-US" sz="2800" b="1" dirty="0">
+              <a:rPr lang="en-US" sz="2200" b="1" dirty="0">
                 <a:solidFill>
                   <a:srgbClr val="F1F5F9"/>
                 </a:solidFill>
@@ -3741,7 +3723,7 @@
               </a:rPr>
               <a:t>Pure engines, an agent that proposes, a human who commits</a:t>
             </a:r>
-            <a:endParaRPr lang="en-US" sz="2800" dirty="0"/>
+            <a:endParaRPr lang="en-US" sz="2200" dirty="0"/>
           </a:p>
         </p:txBody>
       </p:sp>
@@ -3856,7 +3838,7 @@
           </a:fontRef>
         </p:style>
         <p:txBody>
-          <a:bodyPr rtlCol="0" anchor="ctr" wrap="square" lIns="45720" rIns="45720" tIns="18288" bIns="18288"/>
+          <a:bodyPr wrap="square" lIns="45720" tIns="18288" rIns="45720" bIns="18288" rtlCol="0" anchor="ctr"/>
           <a:lstStyle/>
           <a:p>
             <a:pPr algn="ctr"/>
@@ -3923,7 +3905,7 @@
           </a:fontRef>
         </p:style>
         <p:txBody>
-          <a:bodyPr rtlCol="0" anchor="ctr" wrap="square" lIns="45720" rIns="45720" tIns="18288" bIns="18288"/>
+          <a:bodyPr wrap="square" lIns="45720" tIns="18288" rIns="45720" bIns="18288" rtlCol="0" anchor="ctr"/>
           <a:lstStyle/>
           <a:p>
             <a:pPr algn="ctr"/>
@@ -3988,7 +3970,7 @@
           </a:fontRef>
         </p:style>
         <p:txBody>
-          <a:bodyPr rtlCol="0" anchor="ctr" wrap="square" lIns="45720" rIns="45720" tIns="18288" bIns="18288"/>
+          <a:bodyPr wrap="square" lIns="45720" tIns="18288" rIns="45720" bIns="18288" rtlCol="0" anchor="ctr"/>
           <a:lstStyle/>
           <a:p>
             <a:pPr algn="ctr"/>
@@ -4160,7 +4142,7 @@
           </a:fontRef>
         </p:style>
         <p:txBody>
-          <a:bodyPr rtlCol="0" anchor="ctr" wrap="square" lIns="45720" rIns="45720" tIns="18288" bIns="18288"/>
+          <a:bodyPr wrap="square" lIns="45720" tIns="18288" rIns="45720" bIns="18288" rtlCol="0" anchor="ctr"/>
           <a:lstStyle/>
           <a:p>
             <a:pPr algn="ctr"/>
@@ -4295,7 +4277,7 @@
           </a:fontRef>
         </p:style>
         <p:txBody>
-          <a:bodyPr rtlCol="0" anchor="ctr" wrap="square" lIns="45720" rIns="45720" tIns="18288" bIns="18288"/>
+          <a:bodyPr wrap="square" lIns="45720" tIns="18288" rIns="45720" bIns="18288" rtlCol="0" anchor="ctr"/>
           <a:lstStyle/>
           <a:p>
             <a:pPr algn="ctr"/>
@@ -4360,7 +4342,7 @@
           </a:fontRef>
         </p:style>
         <p:txBody>
-          <a:bodyPr rtlCol="0" anchor="ctr" wrap="square" lIns="45720" rIns="45720" tIns="18288" bIns="18288"/>
+          <a:bodyPr wrap="square" lIns="45720" tIns="18288" rIns="45720" bIns="18288" rtlCol="0" anchor="ctr"/>
           <a:lstStyle/>
           <a:p>
             <a:pPr algn="ctr"/>
@@ -4425,7 +4407,7 @@
           </a:fontRef>
         </p:style>
         <p:txBody>
-          <a:bodyPr rtlCol="0" anchor="ctr" wrap="square" lIns="45720" rIns="45720" tIns="18288" bIns="18288"/>
+          <a:bodyPr wrap="square" lIns="45720" tIns="18288" rIns="45720" bIns="18288" rtlCol="0" anchor="ctr"/>
           <a:lstStyle/>
           <a:p>
             <a:pPr algn="ctr"/>
@@ -4490,7 +4472,7 @@
           </a:fontRef>
         </p:style>
         <p:txBody>
-          <a:bodyPr rtlCol="0" anchor="ctr" wrap="square" lIns="45720" rIns="45720" tIns="18288" bIns="18288"/>
+          <a:bodyPr wrap="square" lIns="45720" tIns="18288" rIns="45720" bIns="18288" rtlCol="0" anchor="ctr"/>
           <a:lstStyle/>
           <a:p>
             <a:pPr algn="ctr"/>
@@ -4555,7 +4537,7 @@
           </a:fontRef>
         </p:style>
         <p:txBody>
-          <a:bodyPr rtlCol="0" anchor="ctr" wrap="square" lIns="45720" rIns="45720" tIns="18288" bIns="18288"/>
+          <a:bodyPr wrap="square" lIns="45720" tIns="18288" rIns="45720" bIns="18288" rtlCol="0" anchor="ctr"/>
           <a:lstStyle/>
           <a:p>
             <a:pPr algn="ctr"/>
@@ -4655,7 +4637,7 @@
           </a:fontRef>
         </p:style>
         <p:txBody>
-          <a:bodyPr rtlCol="0" anchor="ctr" wrap="square" lIns="45720" rIns="45720" tIns="18288" bIns="18288"/>
+          <a:bodyPr wrap="square" lIns="45720" tIns="18288" rIns="45720" bIns="18288" rtlCol="0" anchor="ctr"/>
           <a:lstStyle/>
           <a:p>
             <a:pPr algn="ctr"/>
@@ -4720,7 +4702,7 @@
           </a:fontRef>
         </p:style>
         <p:txBody>
-          <a:bodyPr rtlCol="0" anchor="ctr" wrap="square" lIns="45720" rIns="45720" tIns="18288" bIns="18288"/>
+          <a:bodyPr wrap="square" lIns="45720" tIns="18288" rIns="45720" bIns="18288" rtlCol="0" anchor="ctr"/>
           <a:lstStyle/>
           <a:p>
             <a:pPr algn="ctr"/>
@@ -4787,7 +4769,7 @@
           </a:fontRef>
         </p:style>
         <p:txBody>
-          <a:bodyPr rtlCol="0" anchor="ctr" wrap="square" lIns="45720" rIns="45720" tIns="18288" bIns="18288"/>
+          <a:bodyPr wrap="square" lIns="45720" tIns="18288" rIns="45720" bIns="18288" rtlCol="0" anchor="ctr"/>
           <a:lstStyle/>
           <a:p>
             <a:pPr algn="ctr"/>
@@ -5070,7 +5052,7 @@
 </file>
 
 <file path=ppt/theme/theme1.xml><?xml version="1.0" encoding="utf-8"?>
-<a:theme xmlns:thm15="http://schemas.microsoft.com/office/thememl/2012/main" xmlns:a="http://schemas.openxmlformats.org/drawingml/2006/main" name="Office Theme">
+<a:theme xmlns:a="http://schemas.openxmlformats.org/drawingml/2006/main" name="Office Theme">
   <a:themeElements>
     <a:clrScheme name="Office">
       <a:dk1>
@@ -5362,4 +5344,319 @@
     </a:ext>
   </a:extLst>
 </a:theme>
+</file>
+
+<file path=ppt/theme/theme2.xml><?xml version="1.0" encoding="utf-8"?>
+<a:theme xmlns:a="http://schemas.openxmlformats.org/drawingml/2006/main" name="Office Theme">
+  <a:themeElements>
+    <a:clrScheme name="Office">
+      <a:dk1>
+        <a:sysClr val="windowText" lastClr="000000"/>
+      </a:dk1>
+      <a:lt1>
+        <a:sysClr val="window" lastClr="FFFFFF"/>
+      </a:lt1>
+      <a:dk2>
+        <a:srgbClr val="0E2841"/>
+      </a:dk2>
+      <a:lt2>
+        <a:srgbClr val="E8E8E8"/>
+      </a:lt2>
+      <a:accent1>
+        <a:srgbClr val="156082"/>
+      </a:accent1>
+      <a:accent2>
+        <a:srgbClr val="E97132"/>
+      </a:accent2>
+      <a:accent3>
+        <a:srgbClr val="196B24"/>
+      </a:accent3>
+      <a:accent4>
+        <a:srgbClr val="0F9ED5"/>
+      </a:accent4>
+      <a:accent5>
+        <a:srgbClr val="A02B93"/>
+      </a:accent5>
+      <a:accent6>
+        <a:srgbClr val="4EA72E"/>
+      </a:accent6>
+      <a:hlink>
+        <a:srgbClr val="467886"/>
+      </a:hlink>
+      <a:folHlink>
+        <a:srgbClr val="96607D"/>
+      </a:folHlink>
+    </a:clrScheme>
+    <a:fontScheme name="Office">
+      <a:majorFont>
+        <a:latin typeface="Aptos Display" panose="02110004020202020204"/>
+        <a:ea typeface=""/>
+        <a:cs typeface=""/>
+        <a:font script="Jpan" typeface="游ゴシック Light"/>
+        <a:font script="Hang" typeface="맑은 고딕"/>
+        <a:font script="Hans" typeface="等线 Light"/>
+        <a:font script="Hant" typeface="新細明體"/>
+        <a:font script="Arab" typeface="Times New Roman"/>
+        <a:font script="Hebr" typeface="Times New Roman"/>
+        <a:font script="Thai" typeface="Angsana New"/>
+        <a:font script="Ethi" typeface="Nyala"/>
+        <a:font script="Beng" typeface="Vrinda"/>
+        <a:font script="Gujr" typeface="Shruti"/>
+        <a:font script="Khmr" typeface="MoolBoran"/>
+        <a:font script="Knda" typeface="Tunga"/>
+        <a:font script="Guru" typeface="Raavi"/>
+        <a:font script="Cans" typeface="Euphemia"/>
+        <a:font script="Cher" typeface="Plantagenet Cherokee"/>
+        <a:font script="Yiii" typeface="Microsoft Yi Baiti"/>
+        <a:font script="Tibt" typeface="Microsoft Himalaya"/>
+        <a:font script="Thaa" typeface="MV Boli"/>
+        <a:font script="Deva" typeface="Mangal"/>
+        <a:font script="Telu" typeface="Gautami"/>
+        <a:font script="Taml" typeface="Latha"/>
+        <a:font script="Syrc" typeface="Estrangelo Edessa"/>
+        <a:font script="Orya" typeface="Kalinga"/>
+        <a:font script="Mlym" typeface="Kartika"/>
+        <a:font script="Laoo" typeface="DokChampa"/>
+        <a:font script="Sinh" typeface="Iskoola Pota"/>
+        <a:font script="Mong" typeface="Mongolian Baiti"/>
+        <a:font script="Viet" typeface="Times New Roman"/>
+        <a:font script="Uigh" typeface="Microsoft Uighur"/>
+        <a:font script="Geor" typeface="Sylfaen"/>
+        <a:font script="Armn" typeface="Arial"/>
+        <a:font script="Bugi" typeface="Leelawadee UI"/>
+        <a:font script="Bopo" typeface="Microsoft JhengHei"/>
+        <a:font script="Java" typeface="Javanese Text"/>
+        <a:font script="Lisu" typeface="Segoe UI"/>
+        <a:font script="Mymr" typeface="Myanmar Text"/>
+        <a:font script="Nkoo" typeface="Ebrima"/>
+        <a:font script="Olck" typeface="Nirmala UI"/>
+        <a:font script="Osma" typeface="Ebrima"/>
+        <a:font script="Phag" typeface="Phagspa"/>
+        <a:font script="Syrn" typeface="Estrangelo Edessa"/>
+        <a:font script="Syrj" typeface="Estrangelo Edessa"/>
+        <a:font script="Syre" typeface="Estrangelo Edessa"/>
+        <a:font script="Sora" typeface="Nirmala UI"/>
+        <a:font script="Tale" typeface="Microsoft Tai Le"/>
+        <a:font script="Talu" typeface="Microsoft New Tai Lue"/>
+        <a:font script="Tfng" typeface="Ebrima"/>
+      </a:majorFont>
+      <a:minorFont>
+        <a:latin typeface="Aptos" panose="02110004020202020204"/>
+        <a:ea typeface=""/>
+        <a:cs typeface=""/>
+        <a:font script="Jpan" typeface="游ゴシック"/>
+        <a:font script="Hang" typeface="맑은 고딕"/>
+        <a:font script="Hans" typeface="等线"/>
+        <a:font script="Hant" typeface="新細明體"/>
+        <a:font script="Arab" typeface="Arial"/>
+        <a:font script="Hebr" typeface="Arial"/>
+        <a:font script="Thai" typeface="Cordia New"/>
+        <a:font script="Ethi" typeface="Nyala"/>
+        <a:font script="Beng" typeface="Vrinda"/>
+        <a:font script="Gujr" typeface="Shruti"/>
+        <a:font script="Khmr" typeface="DaunPenh"/>
+        <a:font script="Knda" typeface="Tunga"/>
+        <a:font script="Guru" typeface="Raavi"/>
+        <a:font script="Cans" typeface="Euphemia"/>
+        <a:font script="Cher" typeface="Plantagenet Cherokee"/>
+        <a:font script="Yiii" typeface="Microsoft Yi Baiti"/>
+        <a:font script="Tibt" typeface="Microsoft Himalaya"/>
+        <a:font script="Thaa" typeface="MV Boli"/>
+        <a:font script="Deva" typeface="Mangal"/>
+        <a:font script="Telu" typeface="Gautami"/>
+        <a:font script="Taml" typeface="Latha"/>
+        <a:font script="Syrc" typeface="Estrangelo Edessa"/>
+        <a:font script="Orya" typeface="Kalinga"/>
+        <a:font script="Mlym" typeface="Kartika"/>
+        <a:font script="Laoo" typeface="DokChampa"/>
+        <a:font script="Sinh" typeface="Iskoola Pota"/>
+        <a:font script="Mong" typeface="Mongolian Baiti"/>
+        <a:font script="Viet" typeface="Arial"/>
+        <a:font script="Uigh" typeface="Microsoft Uighur"/>
+        <a:font script="Geor" typeface="Sylfaen"/>
+        <a:font script="Armn" typeface="Arial"/>
+        <a:font script="Bugi" typeface="Leelawadee UI"/>
+        <a:font script="Bopo" typeface="Microsoft JhengHei"/>
+        <a:font script="Java" typeface="Javanese Text"/>
+        <a:font script="Lisu" typeface="Segoe UI"/>
+        <a:font script="Mymr" typeface="Myanmar Text"/>
+        <a:font script="Nkoo" typeface="Ebrima"/>
+        <a:font script="Olck" typeface="Nirmala UI"/>
+        <a:font script="Osma" typeface="Ebrima"/>
+        <a:font script="Phag" typeface="Phagspa"/>
+        <a:font script="Syrn" typeface="Estrangelo Edessa"/>
+        <a:font script="Syrj" typeface="Estrangelo Edessa"/>
+        <a:font script="Syre" typeface="Estrangelo Edessa"/>
+        <a:font script="Sora" typeface="Nirmala UI"/>
+        <a:font script="Tale" typeface="Microsoft Tai Le"/>
+        <a:font script="Talu" typeface="Microsoft New Tai Lue"/>
+        <a:font script="Tfng" typeface="Ebrima"/>
+      </a:minorFont>
+    </a:fontScheme>
+    <a:fmtScheme name="Office">
+      <a:fillStyleLst>
+        <a:solidFill>
+          <a:schemeClr val="phClr"/>
+        </a:solidFill>
+        <a:gradFill rotWithShape="1">
+          <a:gsLst>
+            <a:gs pos="0">
+              <a:schemeClr val="phClr">
+                <a:lumMod val="110000"/>
+                <a:satMod val="105000"/>
+                <a:tint val="67000"/>
+              </a:schemeClr>
+            </a:gs>
+            <a:gs pos="50000">
+              <a:schemeClr val="phClr">
+                <a:lumMod val="105000"/>
+                <a:satMod val="103000"/>
+                <a:tint val="73000"/>
+              </a:schemeClr>
+            </a:gs>
+            <a:gs pos="100000">
+              <a:schemeClr val="phClr">
+                <a:lumMod val="105000"/>
+                <a:satMod val="109000"/>
+                <a:tint val="81000"/>
+              </a:schemeClr>
+            </a:gs>
+          </a:gsLst>
+          <a:lin ang="5400000" scaled="0"/>
+        </a:gradFill>
+        <a:gradFill rotWithShape="1">
+          <a:gsLst>
+            <a:gs pos="0">
+              <a:schemeClr val="phClr">
+                <a:satMod val="103000"/>
+                <a:lumMod val="102000"/>
+                <a:tint val="94000"/>
+              </a:schemeClr>
+            </a:gs>
+            <a:gs pos="50000">
+              <a:schemeClr val="phClr">
+                <a:satMod val="110000"/>
+                <a:lumMod val="100000"/>
+                <a:shade val="100000"/>
+              </a:schemeClr>
+            </a:gs>
+            <a:gs pos="100000">
+              <a:schemeClr val="phClr">
+                <a:lumMod val="99000"/>
+                <a:satMod val="120000"/>
+                <a:shade val="78000"/>
+              </a:schemeClr>
+            </a:gs>
+          </a:gsLst>
+          <a:lin ang="5400000" scaled="0"/>
+        </a:gradFill>
+      </a:fillStyleLst>
+      <a:lnStyleLst>
+        <a:ln w="12700" cap="flat" cmpd="sng" algn="ctr">
+          <a:solidFill>
+            <a:schemeClr val="phClr"/>
+          </a:solidFill>
+          <a:prstDash val="solid"/>
+          <a:miter lim="800000"/>
+        </a:ln>
+        <a:ln w="19050" cap="flat" cmpd="sng" algn="ctr">
+          <a:solidFill>
+            <a:schemeClr val="phClr"/>
+          </a:solidFill>
+          <a:prstDash val="solid"/>
+          <a:miter lim="800000"/>
+        </a:ln>
+        <a:ln w="25400" cap="flat" cmpd="sng" algn="ctr">
+          <a:solidFill>
+            <a:schemeClr val="phClr"/>
+          </a:solidFill>
+          <a:prstDash val="solid"/>
+          <a:miter lim="800000"/>
+        </a:ln>
+      </a:lnStyleLst>
+      <a:effectStyleLst>
+        <a:effectStyle>
+          <a:effectLst/>
+        </a:effectStyle>
+        <a:effectStyle>
+          <a:effectLst/>
+        </a:effectStyle>
+        <a:effectStyle>
+          <a:effectLst>
+            <a:outerShdw blurRad="57150" dist="19050" dir="5400000" algn="ctr" rotWithShape="0">
+              <a:srgbClr val="000000">
+                <a:alpha val="63000"/>
+              </a:srgbClr>
+            </a:outerShdw>
+          </a:effectLst>
+        </a:effectStyle>
+      </a:effectStyleLst>
+      <a:bgFillStyleLst>
+        <a:solidFill>
+          <a:schemeClr val="phClr"/>
+        </a:solidFill>
+        <a:solidFill>
+          <a:schemeClr val="phClr">
+            <a:tint val="95000"/>
+            <a:satMod val="170000"/>
+          </a:schemeClr>
+        </a:solidFill>
+        <a:gradFill rotWithShape="1">
+          <a:gsLst>
+            <a:gs pos="0">
+              <a:schemeClr val="phClr">
+                <a:tint val="93000"/>
+                <a:satMod val="150000"/>
+                <a:shade val="98000"/>
+                <a:lumMod val="102000"/>
+              </a:schemeClr>
+            </a:gs>
+            <a:gs pos="50000">
+              <a:schemeClr val="phClr">
+                <a:tint val="98000"/>
+                <a:satMod val="130000"/>
+                <a:shade val="90000"/>
+                <a:lumMod val="103000"/>
+              </a:schemeClr>
+            </a:gs>
+            <a:gs pos="100000">
+              <a:schemeClr val="phClr">
+                <a:shade val="63000"/>
+                <a:satMod val="120000"/>
+              </a:schemeClr>
+            </a:gs>
+          </a:gsLst>
+          <a:lin ang="5400000" scaled="0"/>
+        </a:gradFill>
+      </a:bgFillStyleLst>
+    </a:fmtScheme>
+  </a:themeElements>
+  <a:objectDefaults>
+    <a:lnDef>
+      <a:spPr/>
+      <a:bodyPr/>
+      <a:lstStyle/>
+      <a:style>
+        <a:lnRef idx="2">
+          <a:schemeClr val="accent1"/>
+        </a:lnRef>
+        <a:fillRef idx="0">
+          <a:schemeClr val="accent1"/>
+        </a:fillRef>
+        <a:effectRef idx="1">
+          <a:schemeClr val="accent1"/>
+        </a:effectRef>
+        <a:fontRef idx="minor">
+          <a:schemeClr val="tx1"/>
+        </a:fontRef>
+      </a:style>
+    </a:lnDef>
+  </a:objectDefaults>
+  <a:extraClrSchemeLst/>
+  <a:extLst>
+    <a:ext uri="{05A4C25C-085E-4340-85A3-A5531E510DB2}">
+      <thm15:themeFamily xmlns:thm15="http://schemas.microsoft.com/office/thememl/2012/main" name="Office Theme" id="{2E142A2C-CD16-42D6-873A-C26D2A0506FA}" vid="{1BDDFF52-6CD6-40A5-AB3C-68EB2F1E4D0A}"/>
+    </a:ext>
+  </a:extLst>
+</a:theme>
 </file>
</xml_diff>